<commit_message>
Slide 8: swap capability bullets for a video placeholder
Move the sandbox control list into the spoken script/speaker notes (now covers payout speed and regulator too) and replace the bullets with a centered 16:9 placeholder for the closing screen recording. Keep the infrastructure line; move the v2 'type the scenario' line into narration.

Co-Authored-By: Claude Opus 4.8 <noreply@anthropic.com>
</commit_message>
<xml_diff>
--- a/SLIDES.pptx
+++ b/SLIDES.pptx
@@ -1180,12 +1180,12 @@
           </a:p>
           <a:p>
             <a:r>
-              <a:t>[PLAY THE RECORDING — narrate lightly, don't read every control]</a:t>
-            </a:r>
-          </a:p>
-          <a:p>
-            <a:r>
-              <a:t>"You describe an agent in plain English, set the bank's health and the population mix, write the rumor, even add a counter-signal. Name it, run it, reload it.</a:t>
+              <a:t>[PLAY THE RECORDING — narrate lightly over the controls as they appear]</a:t>
+            </a:r>
+          </a:p>
+          <a:p>
+            <a:r>
+              <a:t>"You describe an agent in plain English, set the bank's health and payout speed, choose the population mix, write the rumor, and optionally drop in a regulator or a counter-signal that talks the agents back. Name it, run it, reload it.</a:t>
             </a:r>
           </a:p>
           <a:p>
@@ -9197,14 +9197,89 @@
       </p:sp>
       <p:sp>
         <p:nvSpPr>
-          <p:cNvPr id="4" name="TextBox 3"/>
+          <p:cNvPr id="4" name="Rounded Rectangle 3"/>
+          <p:cNvSpPr/>
+          <p:nvPr/>
+        </p:nvSpPr>
+        <p:spPr>
+          <a:xfrm>
+            <a:off x="3352647" y="1828800"/>
+            <a:ext cx="5486400" cy="3086100"/>
+          </a:xfrm>
+          <a:prstGeom prst="roundRect">
+            <a:avLst/>
+          </a:prstGeom>
+          <a:solidFill>
+            <a:srgbClr val="17111E"/>
+          </a:solidFill>
+          <a:ln w="15875">
+            <a:solidFill>
+              <a:srgbClr val="76B7B2"/>
+            </a:solidFill>
+          </a:ln>
+          <a:effectLst/>
+        </p:spPr>
+        <p:style>
+          <a:lnRef idx="1">
+            <a:schemeClr val="accent1"/>
+          </a:lnRef>
+          <a:fillRef idx="3">
+            <a:schemeClr val="accent1"/>
+          </a:fillRef>
+          <a:effectRef idx="2">
+            <a:schemeClr val="accent1"/>
+          </a:effectRef>
+          <a:fontRef idx="minor">
+            <a:schemeClr val="lt1"/>
+          </a:fontRef>
+        </p:style>
+        <p:txBody>
+          <a:bodyPr rtlCol="0" anchor="ctr" wrap="square"/>
+          <a:lstStyle/>
+          <a:p>
+            <a:pPr algn="ctr">
+              <a:spcAft>
+                <a:spcPts val="400"/>
+              </a:spcAft>
+            </a:pPr>
+            <a:r>
+              <a:rPr sz="2000" b="1" i="0">
+                <a:solidFill>
+                  <a:srgbClr val="9AA0B5"/>
+                </a:solidFill>
+                <a:latin typeface="Segoe UI"/>
+              </a:rPr>
+              <a:t>▶  Sandbox screen recording</a:t>
+            </a:r>
+          </a:p>
+          <a:p>
+            <a:pPr algn="ctr">
+              <a:spcAft>
+                <a:spcPts val="800"/>
+              </a:spcAft>
+            </a:pPr>
+            <a:r>
+              <a:rPr sz="1200" b="0" i="0">
+                <a:solidFill>
+                  <a:srgbClr val="5A5B70"/>
+                </a:solidFill>
+                <a:latin typeface="Segoe UI"/>
+              </a:rPr>
+              <a:t>insert video here · Playback ▸ Play Full Screen · then delete this box</a:t>
+            </a:r>
+          </a:p>
+        </p:txBody>
+      </p:sp>
+      <p:sp>
+        <p:nvSpPr>
+          <p:cNvPr id="5" name="TextBox 4"/>
           <p:cNvSpPr txBox="1"/>
           <p:nvPr/>
         </p:nvSpPr>
         <p:spPr>
           <a:xfrm>
-            <a:off x="822960" y="2057400"/>
-            <a:ext cx="10515600" cy="2240280"/>
+            <a:off x="822960" y="5120640"/>
+            <a:ext cx="10515600" cy="1097280"/>
           </a:xfrm>
           <a:prstGeom prst="rect">
             <a:avLst/>
@@ -9219,197 +9294,6 @@
           <a:p>
             <a:pPr algn="l">
               <a:lnSpc>
-                <a:spcPct val="125000"/>
-              </a:lnSpc>
-              <a:spcAft>
-                <a:spcPts val="400"/>
-              </a:spcAft>
-            </a:pPr>
-            <a:r>
-              <a:rPr sz="1800" b="0" i="0">
-                <a:solidFill>
-                  <a:srgbClr val="E15759"/>
-                </a:solidFill>
-                <a:latin typeface="Segoe UI"/>
-              </a:rPr>
-              <a:t>•  </a:t>
-            </a:r>
-            <a:r>
-              <a:rPr sz="1800" b="0" i="0">
-                <a:solidFill>
-                  <a:srgbClr val="D7D8E6"/>
-                </a:solidFill>
-                <a:latin typeface="Segoe UI"/>
-              </a:rPr>
-              <a:t>🗣  Describe agents in plain English</a:t>
-            </a:r>
-          </a:p>
-          <a:p>
-            <a:pPr algn="l">
-              <a:lnSpc>
-                <a:spcPct val="125000"/>
-              </a:lnSpc>
-              <a:spcAft>
-                <a:spcPts val="400"/>
-              </a:spcAft>
-            </a:pPr>
-            <a:r>
-              <a:rPr sz="1800" b="0" i="0">
-                <a:solidFill>
-                  <a:srgbClr val="E15759"/>
-                </a:solidFill>
-                <a:latin typeface="Segoe UI"/>
-              </a:rPr>
-              <a:t>•  </a:t>
-            </a:r>
-            <a:r>
-              <a:rPr sz="1800" b="0" i="0">
-                <a:solidFill>
-                  <a:srgbClr val="D7D8E6"/>
-                </a:solidFill>
-                <a:latin typeface="Segoe UI"/>
-              </a:rPr>
-              <a:t>🏦  Set bank health &amp; payout speed</a:t>
-            </a:r>
-          </a:p>
-          <a:p>
-            <a:pPr algn="l">
-              <a:lnSpc>
-                <a:spcPct val="125000"/>
-              </a:lnSpc>
-              <a:spcAft>
-                <a:spcPts val="400"/>
-              </a:spcAft>
-            </a:pPr>
-            <a:r>
-              <a:rPr sz="1800" b="0" i="0">
-                <a:solidFill>
-                  <a:srgbClr val="E15759"/>
-                </a:solidFill>
-                <a:latin typeface="Segoe UI"/>
-              </a:rPr>
-              <a:t>•  </a:t>
-            </a:r>
-            <a:r>
-              <a:rPr sz="1800" b="0" i="0">
-                <a:solidFill>
-                  <a:srgbClr val="D7D8E6"/>
-                </a:solidFill>
-                <a:latin typeface="Segoe UI"/>
-              </a:rPr>
-              <a:t>👥  Choose the population mix</a:t>
-            </a:r>
-          </a:p>
-          <a:p>
-            <a:pPr algn="l">
-              <a:lnSpc>
-                <a:spcPct val="125000"/>
-              </a:lnSpc>
-              <a:spcAft>
-                <a:spcPts val="400"/>
-              </a:spcAft>
-            </a:pPr>
-            <a:r>
-              <a:rPr sz="1800" b="0" i="0">
-                <a:solidFill>
-                  <a:srgbClr val="E15759"/>
-                </a:solidFill>
-                <a:latin typeface="Segoe UI"/>
-              </a:rPr>
-              <a:t>•  </a:t>
-            </a:r>
-            <a:r>
-              <a:rPr sz="1800" b="0" i="0">
-                <a:solidFill>
-                  <a:srgbClr val="D7D8E6"/>
-                </a:solidFill>
-                <a:latin typeface="Segoe UI"/>
-              </a:rPr>
-              <a:t>📰  Write the rumor &amp; its wording</a:t>
-            </a:r>
-          </a:p>
-          <a:p>
-            <a:pPr algn="l">
-              <a:lnSpc>
-                <a:spcPct val="125000"/>
-              </a:lnSpc>
-              <a:spcAft>
-                <a:spcPts val="400"/>
-              </a:spcAft>
-            </a:pPr>
-            <a:r>
-              <a:rPr sz="1800" b="0" i="0">
-                <a:solidFill>
-                  <a:srgbClr val="E15759"/>
-                </a:solidFill>
-                <a:latin typeface="Segoe UI"/>
-              </a:rPr>
-              <a:t>•  </a:t>
-            </a:r>
-            <a:r>
-              <a:rPr sz="1800" b="0" i="0">
-                <a:solidFill>
-                  <a:srgbClr val="D7D8E6"/>
-                </a:solidFill>
-                <a:latin typeface="Segoe UI"/>
-              </a:rPr>
-              <a:t>🟢  Add a reassuring counter-signal     🏛  Drop in a regulator</a:t>
-            </a:r>
-          </a:p>
-          <a:p>
-            <a:pPr algn="l">
-              <a:lnSpc>
-                <a:spcPct val="125000"/>
-              </a:lnSpc>
-              <a:spcAft>
-                <a:spcPts val="400"/>
-              </a:spcAft>
-            </a:pPr>
-            <a:r>
-              <a:rPr sz="1800" b="0" i="0">
-                <a:solidFill>
-                  <a:srgbClr val="E15759"/>
-                </a:solidFill>
-                <a:latin typeface="Segoe UI"/>
-              </a:rPr>
-              <a:t>•  </a:t>
-            </a:r>
-            <a:r>
-              <a:rPr sz="1800" b="0" i="0">
-                <a:solidFill>
-                  <a:srgbClr val="D7D8E6"/>
-                </a:solidFill>
-                <a:latin typeface="Segoe UI"/>
-              </a:rPr>
-              <a:t>💾  Name it · save it · reload it</a:t>
-            </a:r>
-          </a:p>
-        </p:txBody>
-      </p:sp>
-      <p:sp>
-        <p:nvSpPr>
-          <p:cNvPr id="5" name="TextBox 4"/>
-          <p:cNvSpPr txBox="1"/>
-          <p:nvPr/>
-        </p:nvSpPr>
-        <p:spPr>
-          <a:xfrm>
-            <a:off x="822960" y="4572000"/>
-            <a:ext cx="10515600" cy="1737360"/>
-          </a:xfrm>
-          <a:prstGeom prst="rect">
-            <a:avLst/>
-          </a:prstGeom>
-          <a:noFill/>
-        </p:spPr>
-        <p:txBody>
-          <a:bodyPr wrap="square">
-            <a:spAutoFit/>
-          </a:bodyPr>
-          <a:lstStyle/>
-          <a:p>
-            <a:pPr algn="l">
-              <a:lnSpc>
                 <a:spcPct val="122000"/>
               </a:lnSpc>
               <a:spcAft>
@@ -9417,7 +9301,7 @@
               </a:spcAft>
             </a:pPr>
             <a:r>
-              <a:rPr sz="1800" b="0" i="0">
+              <a:rPr sz="1700" b="0" i="0">
                 <a:solidFill>
                   <a:srgbClr val="FFFFFF"/>
                 </a:solidFill>
@@ -9426,7 +9310,7 @@
               <a:t>It's not just a demo — it's </a:t>
             </a:r>
             <a:r>
-              <a:rPr sz="1800" b="0" i="0">
+              <a:rPr sz="1700" b="0" i="0">
                 <a:solidFill>
                   <a:srgbClr val="76B7B2"/>
                 </a:solidFill>
@@ -9435,50 +9319,13 @@
               <a:t>infrastructure</a:t>
             </a:r>
             <a:r>
-              <a:rPr sz="1800" b="0" i="0">
+              <a:rPr sz="1700" b="0" i="0">
                 <a:solidFill>
                   <a:srgbClr val="FFFFFF"/>
                 </a:solidFill>
                 <a:latin typeface="Segoe UI"/>
               </a:rPr>
               <a:t>: a regulator stress-tests delegation rules before approving them, a fintech vets its agent before launch, and real data on who delegates to which model sizes the systemic risk.</a:t>
-            </a:r>
-          </a:p>
-          <a:p>
-            <a:pPr algn="l">
-              <a:lnSpc>
-                <a:spcPct val="122000"/>
-              </a:lnSpc>
-              <a:spcAft>
-                <a:spcPts val="800"/>
-              </a:spcAft>
-            </a:pPr>
-            <a:r>
-              <a:rPr sz="1700" b="0" i="0">
-                <a:solidFill>
-                  <a:srgbClr val="D7D8E6"/>
-                </a:solidFill>
-                <a:latin typeface="Segoe UI"/>
-              </a:rPr>
-              <a:t>Next: just </a:t>
-            </a:r>
-            <a:r>
-              <a:rPr sz="1700" b="0" i="0">
-                <a:solidFill>
-                  <a:srgbClr val="76B7B2"/>
-                </a:solidFill>
-                <a:latin typeface="Segoe UI"/>
-              </a:rPr>
-              <a:t>type</a:t>
-            </a:r>
-            <a:r>
-              <a:rPr sz="1700" b="0" i="0">
-                <a:solidFill>
-                  <a:srgbClr val="D7D8E6"/>
-                </a:solidFill>
-                <a:latin typeface="Segoe UI"/>
-              </a:rPr>
-              <a:t> the scenario — “a stablecoin de-pegs Friday at 9pm” — and the sandbox builds it.</a:t>
             </a:r>
           </a:p>
         </p:txBody>

</xml_diff>

<commit_message>
Slide 8: embed demo video
Co-Authored-By: Claude Opus 4.8 <noreply@anthropic.com>
</commit_message>
<xml_diff>
--- a/SLIDES.pptx
+++ b/SLIDES.pptx
@@ -4,26 +4,29 @@
   <p:sldMasterIdLst>
     <p:sldMasterId id="2147483648" r:id="rId1"/>
   </p:sldMasterIdLst>
+  <p:notesMasterIdLst>
+    <p:notesMasterId r:id="rId19"/>
+  </p:notesMasterIdLst>
   <p:sldIdLst>
-    <p:sldId id="256" r:id="rId7"/>
-    <p:sldId id="257" r:id="rId8"/>
-    <p:sldId id="258" r:id="rId9"/>
-    <p:sldId id="259" r:id="rId10"/>
-    <p:sldId id="260" r:id="rId11"/>
-    <p:sldId id="261" r:id="rId12"/>
-    <p:sldId id="262" r:id="rId13"/>
-    <p:sldId id="263" r:id="rId14"/>
-    <p:sldId id="264" r:id="rId15"/>
-    <p:sldId id="265" r:id="rId16"/>
-    <p:sldId id="266" r:id="rId17"/>
-    <p:sldId id="267" r:id="rId18"/>
-    <p:sldId id="268" r:id="rId19"/>
-    <p:sldId id="269" r:id="rId20"/>
-    <p:sldId id="270" r:id="rId21"/>
-    <p:sldId id="271" r:id="rId22"/>
-    <p:sldId id="272" r:id="rId23"/>
+    <p:sldId id="256" r:id="rId2"/>
+    <p:sldId id="257" r:id="rId3"/>
+    <p:sldId id="258" r:id="rId4"/>
+    <p:sldId id="259" r:id="rId5"/>
+    <p:sldId id="260" r:id="rId6"/>
+    <p:sldId id="261" r:id="rId7"/>
+    <p:sldId id="262" r:id="rId8"/>
+    <p:sldId id="263" r:id="rId9"/>
+    <p:sldId id="264" r:id="rId10"/>
+    <p:sldId id="265" r:id="rId11"/>
+    <p:sldId id="266" r:id="rId12"/>
+    <p:sldId id="267" r:id="rId13"/>
+    <p:sldId id="268" r:id="rId14"/>
+    <p:sldId id="269" r:id="rId15"/>
+    <p:sldId id="270" r:id="rId16"/>
+    <p:sldId id="271" r:id="rId17"/>
+    <p:sldId id="272" r:id="rId18"/>
   </p:sldIdLst>
-  <p:sldSz cx="12191695" cy="6858000" type="screen4x3"/>
+  <p:sldSz cx="12192000" cy="6858000"/>
   <p:notesSz cx="6858000" cy="9144000"/>
   <p:defaultTextStyle>
     <a:defPPr>
@@ -120,11 +123,27 @@
       </a:defRPr>
     </a:lvl9pPr>
   </p:defaultTextStyle>
+  <p:extLst>
+    <p:ext uri="{EFAFB233-063F-42B5-8137-9DF3F51BA10A}">
+      <p15:sldGuideLst xmlns:p15="http://schemas.microsoft.com/office/powerpoint/2012/main">
+        <p15:guide id="1" orient="horz" pos="2160">
+          <p15:clr>
+            <a:srgbClr val="A4A3A4"/>
+          </p15:clr>
+        </p15:guide>
+        <p15:guide id="2" pos="2880">
+          <p15:clr>
+            <a:srgbClr val="A4A3A4"/>
+          </p15:clr>
+        </p15:guide>
+      </p15:sldGuideLst>
+    </p:ext>
+  </p:extLst>
 </p:presentation>
 </file>
 
 <file path=ppt/notesMasters/notesMaster1.xml><?xml version="1.0" encoding="utf-8"?>
-<p:notesMaster xmlns:a="http://schemas.openxmlformats.org/drawingml/2006/main" xmlns:p="http://schemas.openxmlformats.org/presentationml/2006/main" xmlns:r="http://schemas.openxmlformats.org/officeDocument/2006/relationships">
+<p:notesMaster xmlns:a="http://schemas.openxmlformats.org/drawingml/2006/main" xmlns:r="http://schemas.openxmlformats.org/officeDocument/2006/relationships" xmlns:p="http://schemas.openxmlformats.org/presentationml/2006/main">
   <p:cSld>
     <p:bg>
       <p:bgRef idx="1001">
@@ -145,241 +164,16 @@
           <a:chExt cx="0" cy="0"/>
         </a:xfrm>
       </p:grpSpPr>
-      <p:sp>
-        <p:nvSpPr>
-          <p:cNvPr id="2" name="Header Placeholder 1"/>
-          <p:cNvSpPr>
-            <a:spLocks noGrp="1"/>
-          </p:cNvSpPr>
-          <p:nvPr>
-            <p:ph type="hdr" sz="quarter"/>
-          </p:nvPr>
-        </p:nvSpPr>
-        <p:spPr>
-          <a:xfrm>
-            <a:off x="0" y="0"/>
-            <a:ext cx="2971800" cy="457200"/>
-          </a:xfrm>
-          <a:prstGeom prst="rect">
-            <a:avLst/>
-          </a:prstGeom>
-        </p:spPr>
-        <p:txBody>
-          <a:bodyPr vert="horz" lIns="91440" tIns="45720" rIns="91440" bIns="45720" rtlCol="0"/>
-          <a:lstStyle>
-            <a:lvl1pPr algn="l">
-              <a:defRPr sz="1200"/>
-            </a:lvl1pPr>
-          </a:lstStyle>
-          <a:p>
-            <a:endParaRPr lang="en-US"/>
-          </a:p>
-        </p:txBody>
-      </p:sp>
-      <p:sp>
-        <p:nvSpPr>
-          <p:cNvPr id="3" name="Date Placeholder 2"/>
-          <p:cNvSpPr>
-            <a:spLocks noGrp="1"/>
-          </p:cNvSpPr>
-          <p:nvPr>
-            <p:ph type="dt" idx="1"/>
-          </p:nvPr>
-        </p:nvSpPr>
-        <p:spPr>
-          <a:xfrm>
-            <a:off x="3884613" y="0"/>
-            <a:ext cx="2971800" cy="457200"/>
-          </a:xfrm>
-          <a:prstGeom prst="rect">
-            <a:avLst/>
-          </a:prstGeom>
-        </p:spPr>
-        <p:txBody>
-          <a:bodyPr vert="horz" lIns="91440" tIns="45720" rIns="91440" bIns="45720" rtlCol="0"/>
-          <a:lstStyle>
-            <a:lvl1pPr algn="r">
-              <a:defRPr sz="1200"/>
-            </a:lvl1pPr>
-          </a:lstStyle>
-          <a:p>
-            <a:fld id="{0F89C1C7-3DCD-1040-A9CF-14679D8B5DDD}" type="datetimeFigureOut">
-              <a:rPr lang="en-US" smtClean="0"/>
-              <a:t>10/17/16</a:t>
-            </a:fld>
-            <a:endParaRPr lang="en-US"/>
-          </a:p>
-        </p:txBody>
-      </p:sp>
-      <p:sp>
-        <p:nvSpPr>
-          <p:cNvPr id="4" name="Slide Image Placeholder 3"/>
-          <p:cNvSpPr>
-            <a:spLocks noGrp="1" noRot="1" noChangeAspect="1"/>
-          </p:cNvSpPr>
-          <p:nvPr>
-            <p:ph type="sldImg" idx="2"/>
-          </p:nvPr>
-        </p:nvSpPr>
-        <p:spPr>
-          <a:xfrm>
-            <a:off x="1143000" y="685800"/>
-            <a:ext cx="4572000" cy="3429000"/>
-          </a:xfrm>
-          <a:prstGeom prst="rect">
-            <a:avLst/>
-          </a:prstGeom>
-          <a:noFill/>
-          <a:ln w="12700">
-            <a:solidFill>
-              <a:prstClr val="black"/>
-            </a:solidFill>
-          </a:ln>
-        </p:spPr>
-        <p:txBody>
-          <a:bodyPr vert="horz" lIns="91440" tIns="45720" rIns="91440" bIns="45720" rtlCol="0" anchor="ctr"/>
-          <a:lstStyle/>
-          <a:p>
-            <a:endParaRPr lang="en-US"/>
-          </a:p>
-        </p:txBody>
-      </p:sp>
-      <p:sp>
-        <p:nvSpPr>
-          <p:cNvPr id="5" name="Notes Placeholder 4"/>
-          <p:cNvSpPr>
-            <a:spLocks noGrp="1"/>
-          </p:cNvSpPr>
-          <p:nvPr>
-            <p:ph type="body" sz="quarter" idx="3"/>
-          </p:nvPr>
-        </p:nvSpPr>
-        <p:spPr>
-          <a:xfrm>
-            <a:off x="685800" y="4343400"/>
-            <a:ext cx="5486400" cy="4114800"/>
-          </a:xfrm>
-          <a:prstGeom prst="rect">
-            <a:avLst/>
-          </a:prstGeom>
-        </p:spPr>
-        <p:txBody>
-          <a:bodyPr vert="horz" lIns="91440" tIns="45720" rIns="91440" bIns="45720" rtlCol="0"/>
-          <a:lstStyle/>
-          <a:p>
-            <a:pPr lvl="0"/>
-            <a:r>
-              <a:rPr lang="en-US" smtClean="0"/>
-              <a:t>Click to edit Master text styles</a:t>
-            </a:r>
-          </a:p>
-          <a:p>
-            <a:pPr lvl="1"/>
-            <a:r>
-              <a:rPr lang="en-US" smtClean="0"/>
-              <a:t>Second level</a:t>
-            </a:r>
-          </a:p>
-          <a:p>
-            <a:pPr lvl="2"/>
-            <a:r>
-              <a:rPr lang="en-US" smtClean="0"/>
-              <a:t>Third level</a:t>
-            </a:r>
-          </a:p>
-          <a:p>
-            <a:pPr lvl="3"/>
-            <a:r>
-              <a:rPr lang="en-US" smtClean="0"/>
-              <a:t>Fourth level</a:t>
-            </a:r>
-          </a:p>
-          <a:p>
-            <a:pPr lvl="4"/>
-            <a:r>
-              <a:rPr lang="en-US" smtClean="0"/>
-              <a:t>Fifth level</a:t>
-            </a:r>
-            <a:endParaRPr lang="en-US"/>
-          </a:p>
-        </p:txBody>
-      </p:sp>
-      <p:sp>
-        <p:nvSpPr>
-          <p:cNvPr id="6" name="Footer Placeholder 5"/>
-          <p:cNvSpPr>
-            <a:spLocks noGrp="1"/>
-          </p:cNvSpPr>
-          <p:nvPr>
-            <p:ph type="ftr" sz="quarter" idx="4"/>
-          </p:nvPr>
-        </p:nvSpPr>
-        <p:spPr>
-          <a:xfrm>
-            <a:off x="0" y="8685213"/>
-            <a:ext cx="2971800" cy="457200"/>
-          </a:xfrm>
-          <a:prstGeom prst="rect">
-            <a:avLst/>
-          </a:prstGeom>
-        </p:spPr>
-        <p:txBody>
-          <a:bodyPr vert="horz" lIns="91440" tIns="45720" rIns="91440" bIns="45720" rtlCol="0" anchor="b"/>
-          <a:lstStyle>
-            <a:lvl1pPr algn="l">
-              <a:defRPr sz="1200"/>
-            </a:lvl1pPr>
-          </a:lstStyle>
-          <a:p>
-            <a:endParaRPr lang="en-US"/>
-          </a:p>
-        </p:txBody>
-      </p:sp>
-      <p:sp>
-        <p:nvSpPr>
-          <p:cNvPr id="7" name="Slide Number Placeholder 6"/>
-          <p:cNvSpPr>
-            <a:spLocks noGrp="1"/>
-          </p:cNvSpPr>
-          <p:nvPr>
-            <p:ph type="sldNum" sz="quarter" idx="5"/>
-          </p:nvPr>
-        </p:nvSpPr>
-        <p:spPr>
-          <a:xfrm>
-            <a:off x="3884613" y="8685213"/>
-            <a:ext cx="2971800" cy="457200"/>
-          </a:xfrm>
-          <a:prstGeom prst="rect">
-            <a:avLst/>
-          </a:prstGeom>
-        </p:spPr>
-        <p:txBody>
-          <a:bodyPr vert="horz" lIns="91440" tIns="45720" rIns="91440" bIns="45720" rtlCol="0" anchor="b"/>
-          <a:lstStyle>
-            <a:lvl1pPr algn="r">
-              <a:defRPr sz="1200"/>
-            </a:lvl1pPr>
-          </a:lstStyle>
-          <a:p>
-            <a:fld id="{BB5E49A5-4136-284D-997B-48E1D791AD67}" type="slidenum">
-              <a:rPr lang="en-US" smtClean="0"/>
-              <a:t>‹#›</a:t>
-            </a:fld>
-            <a:endParaRPr lang="en-US"/>
-          </a:p>
-        </p:txBody>
-      </p:sp>
     </p:spTree>
     <p:extLst>
       <p:ext uri="{BB962C8B-B14F-4D97-AF65-F5344CB8AC3E}">
-        <p14:creationId xmlns:p14="http://schemas.microsoft.com/office/powerpoint/2010/main" val="2623252185"/>
+        <p14:creationId xmlns:p14="http://schemas.microsoft.com/office/powerpoint/2010/main" val="3882537801"/>
       </p:ext>
     </p:extLst>
   </p:cSld>
   <p:clrMap bg1="lt1" tx1="dk1" bg2="lt2" tx2="dk2" accent1="accent1" accent2="accent2" accent3="accent3" accent4="accent4" accent5="accent5" accent6="accent6" hlink="hlink" folHlink="folHlink"/>
   <p:notesStyle>
-    <a:lvl1pPr marL="0" algn="l" defTabSz="457200" rtl="0" eaLnBrk="1" latinLnBrk="0" hangingPunct="1">
+    <a:lvl1pPr marL="0" algn="l" defTabSz="914400" rtl="0" eaLnBrk="1" latinLnBrk="0" hangingPunct="1">
       <a:defRPr sz="1200" kern="1200">
         <a:solidFill>
           <a:schemeClr val="tx1"/>
@@ -389,7 +183,7 @@
         <a:cs typeface="+mn-cs"/>
       </a:defRPr>
     </a:lvl1pPr>
-    <a:lvl2pPr marL="457200" algn="l" defTabSz="457200" rtl="0" eaLnBrk="1" latinLnBrk="0" hangingPunct="1">
+    <a:lvl2pPr marL="457200" algn="l" defTabSz="914400" rtl="0" eaLnBrk="1" latinLnBrk="0" hangingPunct="1">
       <a:defRPr sz="1200" kern="1200">
         <a:solidFill>
           <a:schemeClr val="tx1"/>
@@ -399,7 +193,7 @@
         <a:cs typeface="+mn-cs"/>
       </a:defRPr>
     </a:lvl2pPr>
-    <a:lvl3pPr marL="914400" algn="l" defTabSz="457200" rtl="0" eaLnBrk="1" latinLnBrk="0" hangingPunct="1">
+    <a:lvl3pPr marL="914400" algn="l" defTabSz="914400" rtl="0" eaLnBrk="1" latinLnBrk="0" hangingPunct="1">
       <a:defRPr sz="1200" kern="1200">
         <a:solidFill>
           <a:schemeClr val="tx1"/>
@@ -409,7 +203,7 @@
         <a:cs typeface="+mn-cs"/>
       </a:defRPr>
     </a:lvl3pPr>
-    <a:lvl4pPr marL="1371600" algn="l" defTabSz="457200" rtl="0" eaLnBrk="1" latinLnBrk="0" hangingPunct="1">
+    <a:lvl4pPr marL="1371600" algn="l" defTabSz="914400" rtl="0" eaLnBrk="1" latinLnBrk="0" hangingPunct="1">
       <a:defRPr sz="1200" kern="1200">
         <a:solidFill>
           <a:schemeClr val="tx1"/>
@@ -419,7 +213,7 @@
         <a:cs typeface="+mn-cs"/>
       </a:defRPr>
     </a:lvl4pPr>
-    <a:lvl5pPr marL="1828800" algn="l" defTabSz="457200" rtl="0" eaLnBrk="1" latinLnBrk="0" hangingPunct="1">
+    <a:lvl5pPr marL="1828800" algn="l" defTabSz="914400" rtl="0" eaLnBrk="1" latinLnBrk="0" hangingPunct="1">
       <a:defRPr sz="1200" kern="1200">
         <a:solidFill>
           <a:schemeClr val="tx1"/>
@@ -429,7 +223,7 @@
         <a:cs typeface="+mn-cs"/>
       </a:defRPr>
     </a:lvl5pPr>
-    <a:lvl6pPr marL="2286000" algn="l" defTabSz="457200" rtl="0" eaLnBrk="1" latinLnBrk="0" hangingPunct="1">
+    <a:lvl6pPr marL="2286000" algn="l" defTabSz="914400" rtl="0" eaLnBrk="1" latinLnBrk="0" hangingPunct="1">
       <a:defRPr sz="1200" kern="1200">
         <a:solidFill>
           <a:schemeClr val="tx1"/>
@@ -439,7 +233,7 @@
         <a:cs typeface="+mn-cs"/>
       </a:defRPr>
     </a:lvl6pPr>
-    <a:lvl7pPr marL="2743200" algn="l" defTabSz="457200" rtl="0" eaLnBrk="1" latinLnBrk="0" hangingPunct="1">
+    <a:lvl7pPr marL="2743200" algn="l" defTabSz="914400" rtl="0" eaLnBrk="1" latinLnBrk="0" hangingPunct="1">
       <a:defRPr sz="1200" kern="1200">
         <a:solidFill>
           <a:schemeClr val="tx1"/>
@@ -449,7 +243,7 @@
         <a:cs typeface="+mn-cs"/>
       </a:defRPr>
     </a:lvl7pPr>
-    <a:lvl8pPr marL="3200400" algn="l" defTabSz="457200" rtl="0" eaLnBrk="1" latinLnBrk="0" hangingPunct="1">
+    <a:lvl8pPr marL="3200400" algn="l" defTabSz="914400" rtl="0" eaLnBrk="1" latinLnBrk="0" hangingPunct="1">
       <a:defRPr sz="1200" kern="1200">
         <a:solidFill>
           <a:schemeClr val="tx1"/>
@@ -459,7 +253,7 @@
         <a:cs typeface="+mn-cs"/>
       </a:defRPr>
     </a:lvl8pPr>
-    <a:lvl9pPr marL="3657600" algn="l" defTabSz="457200" rtl="0" eaLnBrk="1" latinLnBrk="0" hangingPunct="1">
+    <a:lvl9pPr marL="3657600" algn="l" defTabSz="914400" rtl="0" eaLnBrk="1" latinLnBrk="0" hangingPunct="1">
       <a:defRPr sz="1200" kern="1200">
         <a:solidFill>
           <a:schemeClr val="tx1"/>
@@ -474,7 +268,7 @@
 </file>
 
 <file path=ppt/notesSlides/notesSlide1.xml><?xml version="1.0" encoding="utf-8"?>
-<p:notes xmlns:a="http://schemas.openxmlformats.org/drawingml/2006/main" xmlns:p="http://schemas.openxmlformats.org/presentationml/2006/main" xmlns:r="http://schemas.openxmlformats.org/officeDocument/2006/relationships">
+<p:notes xmlns:a="http://schemas.openxmlformats.org/drawingml/2006/main" xmlns:r="http://schemas.openxmlformats.org/officeDocument/2006/relationships" xmlns:p="http://schemas.openxmlformats.org/presentationml/2006/main">
   <p:cSld>
     <p:spTree>
       <p:nvGrpSpPr>
@@ -494,7 +288,7 @@
         <p:nvSpPr>
           <p:cNvPr id="2" name="Slide Image Placeholder 1"/>
           <p:cNvSpPr>
-            <a:spLocks noGrp="1"/>
+            <a:spLocks noGrp="1" noRot="1" noChangeAspect="1"/>
           </p:cNvSpPr>
           <p:nvPr>
             <p:ph type="sldImg" idx="2"/>
@@ -509,7 +303,7 @@
             <a:spLocks noGrp="1"/>
           </p:cNvSpPr>
           <p:nvPr>
-            <p:ph type="body" idx="3" sz="quarter"/>
+            <p:ph type="body" sz="quarter" idx="3"/>
           </p:nvPr>
         </p:nvSpPr>
         <p:spPr/>
@@ -518,17 +312,28 @@
           <a:lstStyle/>
           <a:p>
             <a:r>
+              <a:rPr dirty="0"/>
               <a:t>[0:00 · HOOK]</a:t>
             </a:r>
           </a:p>
           <a:p>
             <a:r>
+              <a:rPr dirty="0"/>
               <a:t>In five years, most of us won't move our own money in a crisis. An AI agent will — checking our accounts, reading the news, deciding whether to pull our savings, in seconds, while we're asleep.</a:t>
             </a:r>
           </a:p>
           <a:p>
             <a:r>
-              <a:t>So we built a sandbox to ask one question: when a bank rumor hits and the depositors are AI agents instead of people — what happens?</a:t>
+              <a:rPr dirty="0"/>
+              <a:t>So</a:t>
+            </a:r>
+            <a:r>
+              <a:rPr lang="en-US" dirty="0"/>
+              <a:t>, together with Claude, we</a:t>
+            </a:r>
+            <a:r>
+              <a:rPr dirty="0"/>
+              <a:t> built a sandbox to ask one question: when a bank rumor hits and the depositors are AI agents instead of people — what happens?</a:t>
             </a:r>
           </a:p>
         </p:txBody>
@@ -540,7 +345,7 @@
             <a:spLocks noGrp="1"/>
           </p:cNvSpPr>
           <p:nvPr>
-            <p:ph type="sldNum" idx="5" sz="quarter"/>
+            <p:ph type="sldNum" sz="quarter" idx="5"/>
           </p:nvPr>
         </p:nvSpPr>
         <p:spPr/>
@@ -554,7 +359,7 @@
 </file>
 
 <file path=ppt/notesSlides/notesSlide2.xml><?xml version="1.0" encoding="utf-8"?>
-<p:notes xmlns:a="http://schemas.openxmlformats.org/drawingml/2006/main" xmlns:p="http://schemas.openxmlformats.org/presentationml/2006/main" xmlns:r="http://schemas.openxmlformats.org/officeDocument/2006/relationships">
+<p:notes xmlns:a="http://schemas.openxmlformats.org/drawingml/2006/main" xmlns:r="http://schemas.openxmlformats.org/officeDocument/2006/relationships" xmlns:p="http://schemas.openxmlformats.org/presentationml/2006/main">
   <p:cSld>
     <p:spTree>
       <p:nvGrpSpPr>
@@ -574,7 +379,7 @@
         <p:nvSpPr>
           <p:cNvPr id="2" name="Slide Image Placeholder 1"/>
           <p:cNvSpPr>
-            <a:spLocks noGrp="1"/>
+            <a:spLocks noGrp="1" noRot="1" noChangeAspect="1"/>
           </p:cNvSpPr>
           <p:nvPr>
             <p:ph type="sldImg" idx="2"/>
@@ -589,7 +394,7 @@
             <a:spLocks noGrp="1"/>
           </p:cNvSpPr>
           <p:nvPr>
-            <p:ph type="body" idx="3" sz="quarter"/>
+            <p:ph type="body" sz="quarter" idx="3"/>
           </p:nvPr>
         </p:nvSpPr>
         <p:spPr/>
@@ -620,7 +425,7 @@
             <a:spLocks noGrp="1"/>
           </p:cNvSpPr>
           <p:nvPr>
-            <p:ph type="sldNum" idx="5" sz="quarter"/>
+            <p:ph type="sldNum" sz="quarter" idx="5"/>
           </p:nvPr>
         </p:nvSpPr>
         <p:spPr/>
@@ -634,7 +439,7 @@
 </file>
 
 <file path=ppt/notesSlides/notesSlide3.xml><?xml version="1.0" encoding="utf-8"?>
-<p:notes xmlns:a="http://schemas.openxmlformats.org/drawingml/2006/main" xmlns:p="http://schemas.openxmlformats.org/presentationml/2006/main" xmlns:r="http://schemas.openxmlformats.org/officeDocument/2006/relationships">
+<p:notes xmlns:a="http://schemas.openxmlformats.org/drawingml/2006/main" xmlns:r="http://schemas.openxmlformats.org/officeDocument/2006/relationships" xmlns:p="http://schemas.openxmlformats.org/presentationml/2006/main">
   <p:cSld>
     <p:spTree>
       <p:nvGrpSpPr>
@@ -654,7 +459,7 @@
         <p:nvSpPr>
           <p:cNvPr id="2" name="Slide Image Placeholder 1"/>
           <p:cNvSpPr>
-            <a:spLocks noGrp="1"/>
+            <a:spLocks noGrp="1" noRot="1" noChangeAspect="1"/>
           </p:cNvSpPr>
           <p:nvPr>
             <p:ph type="sldImg" idx="2"/>
@@ -669,7 +474,7 @@
             <a:spLocks noGrp="1"/>
           </p:cNvSpPr>
           <p:nvPr>
-            <p:ph type="body" idx="3" sz="quarter"/>
+            <p:ph type="body" sz="quarter" idx="3"/>
           </p:nvPr>
         </p:nvSpPr>
         <p:spPr/>
@@ -695,7 +500,7 @@
             <a:spLocks noGrp="1"/>
           </p:cNvSpPr>
           <p:nvPr>
-            <p:ph type="sldNum" idx="5" sz="quarter"/>
+            <p:ph type="sldNum" sz="quarter" idx="5"/>
           </p:nvPr>
         </p:nvSpPr>
         <p:spPr/>
@@ -709,7 +514,7 @@
 </file>
 
 <file path=ppt/notesSlides/notesSlide4.xml><?xml version="1.0" encoding="utf-8"?>
-<p:notes xmlns:a="http://schemas.openxmlformats.org/drawingml/2006/main" xmlns:p="http://schemas.openxmlformats.org/presentationml/2006/main" xmlns:r="http://schemas.openxmlformats.org/officeDocument/2006/relationships">
+<p:notes xmlns:a="http://schemas.openxmlformats.org/drawingml/2006/main" xmlns:r="http://schemas.openxmlformats.org/officeDocument/2006/relationships" xmlns:p="http://schemas.openxmlformats.org/presentationml/2006/main">
   <p:cSld>
     <p:spTree>
       <p:nvGrpSpPr>
@@ -729,7 +534,7 @@
         <p:nvSpPr>
           <p:cNvPr id="2" name="Slide Image Placeholder 1"/>
           <p:cNvSpPr>
-            <a:spLocks noGrp="1"/>
+            <a:spLocks noGrp="1" noRot="1" noChangeAspect="1"/>
           </p:cNvSpPr>
           <p:nvPr>
             <p:ph type="sldImg" idx="2"/>
@@ -744,7 +549,7 @@
             <a:spLocks noGrp="1"/>
           </p:cNvSpPr>
           <p:nvPr>
-            <p:ph type="body" idx="3" sz="quarter"/>
+            <p:ph type="body" sz="quarter" idx="3"/>
           </p:nvPr>
         </p:nvSpPr>
         <p:spPr/>
@@ -756,7 +561,9 @@
               <a:t>[1:00 · LIVE DEMO — switch to dashboard]</a:t>
             </a:r>
           </a:p>
-          <a:p/>
+          <a:p>
+            <a:endParaRPr/>
+          </a:p>
           <a:p>
             <a:r>
               <a:t>LOAD A RUN (Presets page):</a:t>
@@ -777,7 +584,9 @@
               <a:t>"Note the setup: a strong, alarming rumor about Bank A — but the bank is fine. It's solvent. No one's money is actually at risk."  [CLICK Load and view -&gt;]</a:t>
             </a:r>
           </a:p>
-          <a:p/>
+          <a:p>
+            <a:endParaRPr/>
+          </a:p>
           <a:p>
             <a:r>
               <a:t>THE SUMMARY (Inspect page):</a:t>
@@ -788,7 +597,9 @@
               <a:t>"Look at the top strip: this is what twelve agents did with a false alarm. All twelve tried to exit — on a healthy bank."</a:t>
             </a:r>
           </a:p>
-          <a:p/>
+          <a:p>
+            <a:endParaRPr/>
+          </a:p>
           <a:p>
             <a:r>
               <a:t>READ A MIND (spend time here):</a:t>
@@ -814,7 +625,9 @@
               <a:t>"Same rumor, different persona — and listen to the voice. It reasons like a frightened retiree, not a trader. You can tell the personas apart without the labels. That's the heterogeneity doing real work. This is the part I'd never seen before: you can read what the AI was thinking when it decided to run."</a:t>
             </a:r>
           </a:p>
-          <a:p/>
+          <a:p>
+            <a:endParaRPr/>
+          </a:p>
           <a:p>
             <a:r>
               <a:t>[2:50 · THREE FINDINGS — Findings page]</a:t>
@@ -825,7 +638,9 @@
               <a:t>"We ran dozens of these. Three patterns held up. Top to bottom."</a:t>
             </a:r>
           </a:p>
-          <a:p/>
+          <a:p>
+            <a:endParaRPr/>
+          </a:p>
           <a:p>
             <a:r>
               <a:t>FINDING 1 — Same personas, different brains (THE HEADLINE):</a:t>
@@ -836,7 +651,9 @@
               <a:t>"This one surprised us. We froze everything — same personas, same rumor, same healthy bank — and changed one thing: which model decides. Withdrawing here is the wrong call; the bank is fine. With Claude, about half run. With GPT, every one runs. The model alone takes it from a scare to a full collapse — and these bars are replicated four to five runs each, so the ranking is stable. The punchline: if everyone's money is run by the same model, you don't have a diversified crowd — you have a monoculture that panics in lockstep. The model itself is a systemic risk."</a:t>
             </a:r>
           </a:p>
-          <a:p/>
+          <a:p>
+            <a:endParaRPr/>
+          </a:p>
           <a:p>
             <a:r>
               <a:t>FINDING 2 — Speed (scroll down):</a:t>
@@ -847,7 +664,9 @@
               <a:t>"Second: speed. Same scenario at AI speed versus human speed — a 90-second delay per agent. This is the time for half the depositors to decide, not for cash to settle: about 5 seconds versus 15. Roughly three times faster. And moving money is rate-limited, so the requests arrive faster than the bank can pay. It freezes before most cash settles — only 5 of 12 got paid at AI speed, versus 11 of 12 at human speed. Machine speed doesn't move money faster — it freezes the bank faster and locks more people out."</a:t>
             </a:r>
           </a:p>
-          <a:p/>
+          <a:p>
+            <a:endParaRPr/>
+          </a:p>
           <a:p>
             <a:r>
               <a:t>FINDING 3 — The words decide (scroll down):</a:t>
@@ -867,7 +686,7 @@
             <a:spLocks noGrp="1"/>
           </p:cNvSpPr>
           <p:nvPr>
-            <p:ph type="sldNum" idx="5" sz="quarter"/>
+            <p:ph type="sldNum" sz="quarter" idx="5"/>
           </p:nvPr>
         </p:nvSpPr>
         <p:spPr/>
@@ -881,7 +700,7 @@
 </file>
 
 <file path=ppt/notesSlides/notesSlide5.xml><?xml version="1.0" encoding="utf-8"?>
-<p:notes xmlns:a="http://schemas.openxmlformats.org/drawingml/2006/main" xmlns:p="http://schemas.openxmlformats.org/presentationml/2006/main" xmlns:r="http://schemas.openxmlformats.org/officeDocument/2006/relationships">
+<p:notes xmlns:a="http://schemas.openxmlformats.org/drawingml/2006/main" xmlns:r="http://schemas.openxmlformats.org/officeDocument/2006/relationships" xmlns:p="http://schemas.openxmlformats.org/presentationml/2006/main">
   <p:cSld>
     <p:spTree>
       <p:nvGrpSpPr>
@@ -901,7 +720,7 @@
         <p:nvSpPr>
           <p:cNvPr id="2" name="Slide Image Placeholder 1"/>
           <p:cNvSpPr>
-            <a:spLocks noGrp="1"/>
+            <a:spLocks noGrp="1" noRot="1" noChangeAspect="1"/>
           </p:cNvSpPr>
           <p:nvPr>
             <p:ph type="sldImg" idx="2"/>
@@ -916,7 +735,7 @@
             <a:spLocks noGrp="1"/>
           </p:cNvSpPr>
           <p:nvPr>
-            <p:ph type="body" idx="3" sz="quarter"/>
+            <p:ph type="body" sz="quarter" idx="3"/>
           </p:nvPr>
         </p:nvSpPr>
         <p:spPr/>
@@ -942,7 +761,7 @@
             <a:spLocks noGrp="1"/>
           </p:cNvSpPr>
           <p:nvPr>
-            <p:ph type="sldNum" idx="5" sz="quarter"/>
+            <p:ph type="sldNum" sz="quarter" idx="5"/>
           </p:nvPr>
         </p:nvSpPr>
         <p:spPr/>
@@ -956,7 +775,7 @@
 </file>
 
 <file path=ppt/notesSlides/notesSlide6.xml><?xml version="1.0" encoding="utf-8"?>
-<p:notes xmlns:a="http://schemas.openxmlformats.org/drawingml/2006/main" xmlns:p="http://schemas.openxmlformats.org/presentationml/2006/main" xmlns:r="http://schemas.openxmlformats.org/officeDocument/2006/relationships">
+<p:notes xmlns:a="http://schemas.openxmlformats.org/drawingml/2006/main" xmlns:r="http://schemas.openxmlformats.org/officeDocument/2006/relationships" xmlns:p="http://schemas.openxmlformats.org/presentationml/2006/main">
   <p:cSld>
     <p:spTree>
       <p:nvGrpSpPr>
@@ -976,7 +795,7 @@
         <p:nvSpPr>
           <p:cNvPr id="2" name="Slide Image Placeholder 1"/>
           <p:cNvSpPr>
-            <a:spLocks noGrp="1"/>
+            <a:spLocks noGrp="1" noRot="1" noChangeAspect="1"/>
           </p:cNvSpPr>
           <p:nvPr>
             <p:ph type="sldImg" idx="2"/>
@@ -991,7 +810,7 @@
             <a:spLocks noGrp="1"/>
           </p:cNvSpPr>
           <p:nvPr>
-            <p:ph type="body" idx="3" sz="quarter"/>
+            <p:ph type="body" sz="quarter" idx="3"/>
           </p:nvPr>
         </p:nvSpPr>
         <p:spPr/>
@@ -1017,7 +836,7 @@
             <a:spLocks noGrp="1"/>
           </p:cNvSpPr>
           <p:nvPr>
-            <p:ph type="sldNum" idx="5" sz="quarter"/>
+            <p:ph type="sldNum" sz="quarter" idx="5"/>
           </p:nvPr>
         </p:nvSpPr>
         <p:spPr/>
@@ -1031,7 +850,7 @@
 </file>
 
 <file path=ppt/notesSlides/notesSlide7.xml><?xml version="1.0" encoding="utf-8"?>
-<p:notes xmlns:a="http://schemas.openxmlformats.org/drawingml/2006/main" xmlns:p="http://schemas.openxmlformats.org/presentationml/2006/main" xmlns:r="http://schemas.openxmlformats.org/officeDocument/2006/relationships">
+<p:notes xmlns:a="http://schemas.openxmlformats.org/drawingml/2006/main" xmlns:r="http://schemas.openxmlformats.org/officeDocument/2006/relationships" xmlns:p="http://schemas.openxmlformats.org/presentationml/2006/main">
   <p:cSld>
     <p:spTree>
       <p:nvGrpSpPr>
@@ -1051,7 +870,7 @@
         <p:nvSpPr>
           <p:cNvPr id="2" name="Slide Image Placeholder 1"/>
           <p:cNvSpPr>
-            <a:spLocks noGrp="1"/>
+            <a:spLocks noGrp="1" noRot="1" noChangeAspect="1"/>
           </p:cNvSpPr>
           <p:nvPr>
             <p:ph type="sldImg" idx="2"/>
@@ -1066,7 +885,7 @@
             <a:spLocks noGrp="1"/>
           </p:cNvSpPr>
           <p:nvPr>
-            <p:ph type="body" idx="3" sz="quarter"/>
+            <p:ph type="body" sz="quarter" idx="3"/>
           </p:nvPr>
         </p:nvSpPr>
         <p:spPr/>
@@ -1112,7 +931,7 @@
             <a:spLocks noGrp="1"/>
           </p:cNvSpPr>
           <p:nvPr>
-            <p:ph type="sldNum" idx="5" sz="quarter"/>
+            <p:ph type="sldNum" sz="quarter" idx="5"/>
           </p:nvPr>
         </p:nvSpPr>
         <p:spPr/>
@@ -1126,7 +945,7 @@
 </file>
 
 <file path=ppt/notesSlides/notesSlide8.xml><?xml version="1.0" encoding="utf-8"?>
-<p:notes xmlns:a="http://schemas.openxmlformats.org/drawingml/2006/main" xmlns:p="http://schemas.openxmlformats.org/presentationml/2006/main" xmlns:r="http://schemas.openxmlformats.org/officeDocument/2006/relationships">
+<p:notes xmlns:a="http://schemas.openxmlformats.org/drawingml/2006/main" xmlns:r="http://schemas.openxmlformats.org/officeDocument/2006/relationships" xmlns:p="http://schemas.openxmlformats.org/presentationml/2006/main">
   <p:cSld>
     <p:spTree>
       <p:nvGrpSpPr>
@@ -1146,7 +965,7 @@
         <p:nvSpPr>
           <p:cNvPr id="2" name="Slide Image Placeholder 1"/>
           <p:cNvSpPr>
-            <a:spLocks noGrp="1"/>
+            <a:spLocks noGrp="1" noRot="1" noChangeAspect="1"/>
           </p:cNvSpPr>
           <p:nvPr>
             <p:ph type="sldImg" idx="2"/>
@@ -1161,7 +980,7 @@
             <a:spLocks noGrp="1"/>
           </p:cNvSpPr>
           <p:nvPr>
-            <p:ph type="body" idx="3" sz="quarter"/>
+            <p:ph type="body" sz="quarter" idx="3"/>
           </p:nvPr>
         </p:nvSpPr>
         <p:spPr/>
@@ -1170,31 +989,37 @@
           <a:lstStyle/>
           <a:p>
             <a:r>
+              <a:rPr dirty="0"/>
               <a:t>[5:30 · SANDBOX + CLOSE]</a:t>
             </a:r>
           </a:p>
           <a:p>
             <a:r>
+              <a:rPr dirty="0"/>
               <a:t>"We didn't hard-code these scenarios. It all runs on a sandbox where you build any run. Here's a short recording."</a:t>
             </a:r>
           </a:p>
           <a:p>
             <a:r>
+              <a:rPr dirty="0"/>
               <a:t>[PLAY THE RECORDING — narrate lightly over the controls as they appear]</a:t>
             </a:r>
           </a:p>
           <a:p>
             <a:r>
+              <a:rPr dirty="0"/>
               <a:t>"You describe an agent in plain English, set the bank's health and payout speed, choose the population mix, write the rumor, and optionally drop in a regulator or a counter-signal that talks the agents back. Name it, run it, reload it.</a:t>
             </a:r>
           </a:p>
           <a:p>
             <a:r>
+              <a:rPr dirty="0"/>
               <a:t>(As the result lands) Same engine, different scenario. And this is really infrastructure: a regulator can stress-test its delegation rules before approving them, a fintech can test its agent before launch — and as you feed in real data on who delegates to which model, you can size the systemic risk we found here. Eventually you just type the crisis and the sandbox builds it. Twelve agents is the start — this is how anyone probes the next one. Thank you — happy to dig into any of it."</a:t>
             </a:r>
           </a:p>
           <a:p>
             <a:r>
+              <a:rPr dirty="0"/>
               <a:t>[Recording: ~30-40s, end on the Inspect view. Pre-rendered — do not run live.]</a:t>
             </a:r>
           </a:p>
@@ -1207,7 +1032,7 @@
             <a:spLocks noGrp="1"/>
           </p:cNvSpPr>
           <p:nvPr>
-            <p:ph type="sldNum" idx="5" sz="quarter"/>
+            <p:ph type="sldNum" sz="quarter" idx="5"/>
           </p:nvPr>
         </p:nvSpPr>
         <p:spPr/>
@@ -1258,10 +1083,9 @@
           <a:lstStyle/>
           <a:p>
             <a:r>
-              <a:rPr lang="en-US" smtClean="0"/>
+              <a:rPr lang="en-US"/>
               <a:t>Click to edit Master title style</a:t>
             </a:r>
-            <a:endParaRPr lang="en-US"/>
           </a:p>
         </p:txBody>
       </p:sp>
@@ -1377,10 +1201,9 @@
           </a:lstStyle>
           <a:p>
             <a:r>
-              <a:rPr lang="en-US" smtClean="0"/>
+              <a:rPr lang="en-US"/>
               <a:t>Click to edit Master subtitle style</a:t>
             </a:r>
-            <a:endParaRPr lang="en-US"/>
           </a:p>
         </p:txBody>
       </p:sp>
@@ -1401,7 +1224,7 @@
           <a:p>
             <a:fld id="{5BCAD085-E8A6-8845-BD4E-CB4CCA059FC4}" type="datetimeFigureOut">
               <a:rPr lang="en-US" smtClean="0"/>
-              <a:t>1/27/13</a:t>
+              <a:t>2026-05-31</a:t>
             </a:fld>
             <a:endParaRPr lang="en-US"/>
           </a:p>
@@ -1495,10 +1318,9 @@
           <a:lstStyle/>
           <a:p>
             <a:r>
-              <a:rPr lang="en-US" smtClean="0"/>
+              <a:rPr lang="en-US"/>
               <a:t>Click to edit Master title style</a:t>
             </a:r>
-            <a:endParaRPr lang="en-US"/>
           </a:p>
         </p:txBody>
       </p:sp>
@@ -1519,38 +1341,37 @@
           <a:p>
             <a:pPr lvl="0"/>
             <a:r>
-              <a:rPr lang="en-US" smtClean="0"/>
+              <a:rPr lang="en-US"/>
               <a:t>Click to edit Master text styles</a:t>
             </a:r>
           </a:p>
           <a:p>
             <a:pPr lvl="1"/>
             <a:r>
-              <a:rPr lang="en-US" smtClean="0"/>
+              <a:rPr lang="en-US"/>
               <a:t>Second level</a:t>
             </a:r>
           </a:p>
           <a:p>
             <a:pPr lvl="2"/>
             <a:r>
-              <a:rPr lang="en-US" smtClean="0"/>
+              <a:rPr lang="en-US"/>
               <a:t>Third level</a:t>
             </a:r>
           </a:p>
           <a:p>
             <a:pPr lvl="3"/>
             <a:r>
-              <a:rPr lang="en-US" smtClean="0"/>
+              <a:rPr lang="en-US"/>
               <a:t>Fourth level</a:t>
             </a:r>
           </a:p>
           <a:p>
             <a:pPr lvl="4"/>
             <a:r>
-              <a:rPr lang="en-US" smtClean="0"/>
+              <a:rPr lang="en-US"/>
               <a:t>Fifth level</a:t>
             </a:r>
-            <a:endParaRPr lang="en-US"/>
           </a:p>
         </p:txBody>
       </p:sp>
@@ -1571,7 +1392,7 @@
           <a:p>
             <a:fld id="{5BCAD085-E8A6-8845-BD4E-CB4CCA059FC4}" type="datetimeFigureOut">
               <a:rPr lang="en-US" smtClean="0"/>
-              <a:t>1/27/13</a:t>
+              <a:t>2026-05-31</a:t>
             </a:fld>
             <a:endParaRPr lang="en-US"/>
           </a:p>
@@ -1670,10 +1491,9 @@
           <a:lstStyle/>
           <a:p>
             <a:r>
-              <a:rPr lang="en-US" smtClean="0"/>
+              <a:rPr lang="en-US"/>
               <a:t>Click to edit Master title style</a:t>
             </a:r>
-            <a:endParaRPr lang="en-US"/>
           </a:p>
         </p:txBody>
       </p:sp>
@@ -1699,38 +1519,37 @@
           <a:p>
             <a:pPr lvl="0"/>
             <a:r>
-              <a:rPr lang="en-US" smtClean="0"/>
+              <a:rPr lang="en-US"/>
               <a:t>Click to edit Master text styles</a:t>
             </a:r>
           </a:p>
           <a:p>
             <a:pPr lvl="1"/>
             <a:r>
-              <a:rPr lang="en-US" smtClean="0"/>
+              <a:rPr lang="en-US"/>
               <a:t>Second level</a:t>
             </a:r>
           </a:p>
           <a:p>
             <a:pPr lvl="2"/>
             <a:r>
-              <a:rPr lang="en-US" smtClean="0"/>
+              <a:rPr lang="en-US"/>
               <a:t>Third level</a:t>
             </a:r>
           </a:p>
           <a:p>
             <a:pPr lvl="3"/>
             <a:r>
-              <a:rPr lang="en-US" smtClean="0"/>
+              <a:rPr lang="en-US"/>
               <a:t>Fourth level</a:t>
             </a:r>
           </a:p>
           <a:p>
             <a:pPr lvl="4"/>
             <a:r>
-              <a:rPr lang="en-US" smtClean="0"/>
+              <a:rPr lang="en-US"/>
               <a:t>Fifth level</a:t>
             </a:r>
-            <a:endParaRPr lang="en-US"/>
           </a:p>
         </p:txBody>
       </p:sp>
@@ -1751,7 +1570,7 @@
           <a:p>
             <a:fld id="{5BCAD085-E8A6-8845-BD4E-CB4CCA059FC4}" type="datetimeFigureOut">
               <a:rPr lang="en-US" smtClean="0"/>
-              <a:t>1/27/13</a:t>
+              <a:t>2026-05-31</a:t>
             </a:fld>
             <a:endParaRPr lang="en-US"/>
           </a:p>
@@ -1845,10 +1664,9 @@
           <a:lstStyle/>
           <a:p>
             <a:r>
-              <a:rPr lang="en-US" smtClean="0"/>
+              <a:rPr lang="en-US"/>
               <a:t>Click to edit Master title style</a:t>
             </a:r>
-            <a:endParaRPr lang="en-US"/>
           </a:p>
         </p:txBody>
       </p:sp>
@@ -1869,38 +1687,37 @@
           <a:p>
             <a:pPr lvl="0"/>
             <a:r>
-              <a:rPr lang="en-US" smtClean="0"/>
+              <a:rPr lang="en-US"/>
               <a:t>Click to edit Master text styles</a:t>
             </a:r>
           </a:p>
           <a:p>
             <a:pPr lvl="1"/>
             <a:r>
-              <a:rPr lang="en-US" smtClean="0"/>
+              <a:rPr lang="en-US"/>
               <a:t>Second level</a:t>
             </a:r>
           </a:p>
           <a:p>
             <a:pPr lvl="2"/>
             <a:r>
-              <a:rPr lang="en-US" smtClean="0"/>
+              <a:rPr lang="en-US"/>
               <a:t>Third level</a:t>
             </a:r>
           </a:p>
           <a:p>
             <a:pPr lvl="3"/>
             <a:r>
-              <a:rPr lang="en-US" smtClean="0"/>
+              <a:rPr lang="en-US"/>
               <a:t>Fourth level</a:t>
             </a:r>
           </a:p>
           <a:p>
             <a:pPr lvl="4"/>
             <a:r>
-              <a:rPr lang="en-US" smtClean="0"/>
+              <a:rPr lang="en-US"/>
               <a:t>Fifth level</a:t>
             </a:r>
-            <a:endParaRPr lang="en-US"/>
           </a:p>
         </p:txBody>
       </p:sp>
@@ -1921,7 +1738,7 @@
           <a:p>
             <a:fld id="{5BCAD085-E8A6-8845-BD4E-CB4CCA059FC4}" type="datetimeFigureOut">
               <a:rPr lang="en-US" smtClean="0"/>
-              <a:t>1/27/13</a:t>
+              <a:t>2026-05-31</a:t>
             </a:fld>
             <a:endParaRPr lang="en-US"/>
           </a:p>
@@ -2024,10 +1841,9 @@
           </a:lstStyle>
           <a:p>
             <a:r>
-              <a:rPr lang="en-US" smtClean="0"/>
+              <a:rPr lang="en-US"/>
               <a:t>Click to edit Master title style</a:t>
             </a:r>
-            <a:endParaRPr lang="en-US"/>
           </a:p>
         </p:txBody>
       </p:sp>
@@ -2144,7 +1960,7 @@
           <a:p>
             <a:pPr lvl="0"/>
             <a:r>
-              <a:rPr lang="en-US" smtClean="0"/>
+              <a:rPr lang="en-US"/>
               <a:t>Click to edit Master text styles</a:t>
             </a:r>
           </a:p>
@@ -2167,7 +1983,7 @@
           <a:p>
             <a:fld id="{5BCAD085-E8A6-8845-BD4E-CB4CCA059FC4}" type="datetimeFigureOut">
               <a:rPr lang="en-US" smtClean="0"/>
-              <a:t>1/27/13</a:t>
+              <a:t>2026-05-31</a:t>
             </a:fld>
             <a:endParaRPr lang="en-US"/>
           </a:p>
@@ -2261,10 +2077,9 @@
           <a:lstStyle/>
           <a:p>
             <a:r>
-              <a:rPr lang="en-US" smtClean="0"/>
+              <a:rPr lang="en-US"/>
               <a:t>Click to edit Master title style</a:t>
             </a:r>
-            <a:endParaRPr lang="en-US"/>
           </a:p>
         </p:txBody>
       </p:sp>
@@ -2318,38 +2133,37 @@
           <a:p>
             <a:pPr lvl="0"/>
             <a:r>
-              <a:rPr lang="en-US" smtClean="0"/>
+              <a:rPr lang="en-US"/>
               <a:t>Click to edit Master text styles</a:t>
             </a:r>
           </a:p>
           <a:p>
             <a:pPr lvl="1"/>
             <a:r>
-              <a:rPr lang="en-US" smtClean="0"/>
+              <a:rPr lang="en-US"/>
               <a:t>Second level</a:t>
             </a:r>
           </a:p>
           <a:p>
             <a:pPr lvl="2"/>
             <a:r>
-              <a:rPr lang="en-US" smtClean="0"/>
+              <a:rPr lang="en-US"/>
               <a:t>Third level</a:t>
             </a:r>
           </a:p>
           <a:p>
             <a:pPr lvl="3"/>
             <a:r>
-              <a:rPr lang="en-US" smtClean="0"/>
+              <a:rPr lang="en-US"/>
               <a:t>Fourth level</a:t>
             </a:r>
           </a:p>
           <a:p>
             <a:pPr lvl="4"/>
             <a:r>
-              <a:rPr lang="en-US" smtClean="0"/>
+              <a:rPr lang="en-US"/>
               <a:t>Fifth level</a:t>
             </a:r>
-            <a:endParaRPr lang="en-US"/>
           </a:p>
         </p:txBody>
       </p:sp>
@@ -2403,38 +2217,37 @@
           <a:p>
             <a:pPr lvl="0"/>
             <a:r>
-              <a:rPr lang="en-US" smtClean="0"/>
+              <a:rPr lang="en-US"/>
               <a:t>Click to edit Master text styles</a:t>
             </a:r>
           </a:p>
           <a:p>
             <a:pPr lvl="1"/>
             <a:r>
-              <a:rPr lang="en-US" smtClean="0"/>
+              <a:rPr lang="en-US"/>
               <a:t>Second level</a:t>
             </a:r>
           </a:p>
           <a:p>
             <a:pPr lvl="2"/>
             <a:r>
-              <a:rPr lang="en-US" smtClean="0"/>
+              <a:rPr lang="en-US"/>
               <a:t>Third level</a:t>
             </a:r>
           </a:p>
           <a:p>
             <a:pPr lvl="3"/>
             <a:r>
-              <a:rPr lang="en-US" smtClean="0"/>
+              <a:rPr lang="en-US"/>
               <a:t>Fourth level</a:t>
             </a:r>
           </a:p>
           <a:p>
             <a:pPr lvl="4"/>
             <a:r>
-              <a:rPr lang="en-US" smtClean="0"/>
+              <a:rPr lang="en-US"/>
               <a:t>Fifth level</a:t>
             </a:r>
-            <a:endParaRPr lang="en-US"/>
           </a:p>
         </p:txBody>
       </p:sp>
@@ -2455,7 +2268,7 @@
           <a:p>
             <a:fld id="{5BCAD085-E8A6-8845-BD4E-CB4CCA059FC4}" type="datetimeFigureOut">
               <a:rPr lang="en-US" smtClean="0"/>
-              <a:t>1/27/13</a:t>
+              <a:t>2026-05-31</a:t>
             </a:fld>
             <a:endParaRPr lang="en-US"/>
           </a:p>
@@ -2553,10 +2366,9 @@
           </a:lstStyle>
           <a:p>
             <a:r>
-              <a:rPr lang="en-US" smtClean="0"/>
+              <a:rPr lang="en-US"/>
               <a:t>Click to edit Master title style</a:t>
             </a:r>
-            <a:endParaRPr lang="en-US"/>
           </a:p>
         </p:txBody>
       </p:sp>
@@ -2619,7 +2431,7 @@
           <a:p>
             <a:pPr lvl="0"/>
             <a:r>
-              <a:rPr lang="en-US" smtClean="0"/>
+              <a:rPr lang="en-US"/>
               <a:t>Click to edit Master text styles</a:t>
             </a:r>
           </a:p>
@@ -2675,38 +2487,37 @@
           <a:p>
             <a:pPr lvl="0"/>
             <a:r>
-              <a:rPr lang="en-US" smtClean="0"/>
+              <a:rPr lang="en-US"/>
               <a:t>Click to edit Master text styles</a:t>
             </a:r>
           </a:p>
           <a:p>
             <a:pPr lvl="1"/>
             <a:r>
-              <a:rPr lang="en-US" smtClean="0"/>
+              <a:rPr lang="en-US"/>
               <a:t>Second level</a:t>
             </a:r>
           </a:p>
           <a:p>
             <a:pPr lvl="2"/>
             <a:r>
-              <a:rPr lang="en-US" smtClean="0"/>
+              <a:rPr lang="en-US"/>
               <a:t>Third level</a:t>
             </a:r>
           </a:p>
           <a:p>
             <a:pPr lvl="3"/>
             <a:r>
-              <a:rPr lang="en-US" smtClean="0"/>
+              <a:rPr lang="en-US"/>
               <a:t>Fourth level</a:t>
             </a:r>
           </a:p>
           <a:p>
             <a:pPr lvl="4"/>
             <a:r>
-              <a:rPr lang="en-US" smtClean="0"/>
+              <a:rPr lang="en-US"/>
               <a:t>Fifth level</a:t>
             </a:r>
-            <a:endParaRPr lang="en-US"/>
           </a:p>
         </p:txBody>
       </p:sp>
@@ -2769,7 +2580,7 @@
           <a:p>
             <a:pPr lvl="0"/>
             <a:r>
-              <a:rPr lang="en-US" smtClean="0"/>
+              <a:rPr lang="en-US"/>
               <a:t>Click to edit Master text styles</a:t>
             </a:r>
           </a:p>
@@ -2825,38 +2636,37 @@
           <a:p>
             <a:pPr lvl="0"/>
             <a:r>
-              <a:rPr lang="en-US" smtClean="0"/>
+              <a:rPr lang="en-US"/>
               <a:t>Click to edit Master text styles</a:t>
             </a:r>
           </a:p>
           <a:p>
             <a:pPr lvl="1"/>
             <a:r>
-              <a:rPr lang="en-US" smtClean="0"/>
+              <a:rPr lang="en-US"/>
               <a:t>Second level</a:t>
             </a:r>
           </a:p>
           <a:p>
             <a:pPr lvl="2"/>
             <a:r>
-              <a:rPr lang="en-US" smtClean="0"/>
+              <a:rPr lang="en-US"/>
               <a:t>Third level</a:t>
             </a:r>
           </a:p>
           <a:p>
             <a:pPr lvl="3"/>
             <a:r>
-              <a:rPr lang="en-US" smtClean="0"/>
+              <a:rPr lang="en-US"/>
               <a:t>Fourth level</a:t>
             </a:r>
           </a:p>
           <a:p>
             <a:pPr lvl="4"/>
             <a:r>
-              <a:rPr lang="en-US" smtClean="0"/>
+              <a:rPr lang="en-US"/>
               <a:t>Fifth level</a:t>
             </a:r>
-            <a:endParaRPr lang="en-US"/>
           </a:p>
         </p:txBody>
       </p:sp>
@@ -2877,7 +2687,7 @@
           <a:p>
             <a:fld id="{5BCAD085-E8A6-8845-BD4E-CB4CCA059FC4}" type="datetimeFigureOut">
               <a:rPr lang="en-US" smtClean="0"/>
-              <a:t>1/27/13</a:t>
+              <a:t>2026-05-31</a:t>
             </a:fld>
             <a:endParaRPr lang="en-US"/>
           </a:p>
@@ -2971,10 +2781,9 @@
           <a:lstStyle/>
           <a:p>
             <a:r>
-              <a:rPr lang="en-US" smtClean="0"/>
+              <a:rPr lang="en-US"/>
               <a:t>Click to edit Master title style</a:t>
             </a:r>
-            <a:endParaRPr lang="en-US"/>
           </a:p>
         </p:txBody>
       </p:sp>
@@ -2995,7 +2804,7 @@
           <a:p>
             <a:fld id="{5BCAD085-E8A6-8845-BD4E-CB4CCA059FC4}" type="datetimeFigureOut">
               <a:rPr lang="en-US" smtClean="0"/>
-              <a:t>1/27/13</a:t>
+              <a:t>2026-05-31</a:t>
             </a:fld>
             <a:endParaRPr lang="en-US"/>
           </a:p>
@@ -3090,7 +2899,7 @@
           <a:p>
             <a:fld id="{5BCAD085-E8A6-8845-BD4E-CB4CCA059FC4}" type="datetimeFigureOut">
               <a:rPr lang="en-US" smtClean="0"/>
-              <a:t>1/27/13</a:t>
+              <a:t>2026-05-31</a:t>
             </a:fld>
             <a:endParaRPr lang="en-US"/>
           </a:p>
@@ -3193,10 +3002,9 @@
           </a:lstStyle>
           <a:p>
             <a:r>
-              <a:rPr lang="en-US" smtClean="0"/>
+              <a:rPr lang="en-US"/>
               <a:t>Click to edit Master title style</a:t>
             </a:r>
-            <a:endParaRPr lang="en-US"/>
           </a:p>
         </p:txBody>
       </p:sp>
@@ -3250,38 +3058,37 @@
           <a:p>
             <a:pPr lvl="0"/>
             <a:r>
-              <a:rPr lang="en-US" smtClean="0"/>
+              <a:rPr lang="en-US"/>
               <a:t>Click to edit Master text styles</a:t>
             </a:r>
           </a:p>
           <a:p>
             <a:pPr lvl="1"/>
             <a:r>
-              <a:rPr lang="en-US" smtClean="0"/>
+              <a:rPr lang="en-US"/>
               <a:t>Second level</a:t>
             </a:r>
           </a:p>
           <a:p>
             <a:pPr lvl="2"/>
             <a:r>
-              <a:rPr lang="en-US" smtClean="0"/>
+              <a:rPr lang="en-US"/>
               <a:t>Third level</a:t>
             </a:r>
           </a:p>
           <a:p>
             <a:pPr lvl="3"/>
             <a:r>
-              <a:rPr lang="en-US" smtClean="0"/>
+              <a:rPr lang="en-US"/>
               <a:t>Fourth level</a:t>
             </a:r>
           </a:p>
           <a:p>
             <a:pPr lvl="4"/>
             <a:r>
-              <a:rPr lang="en-US" smtClean="0"/>
+              <a:rPr lang="en-US"/>
               <a:t>Fifth level</a:t>
             </a:r>
-            <a:endParaRPr lang="en-US"/>
           </a:p>
         </p:txBody>
       </p:sp>
@@ -3344,7 +3151,7 @@
           <a:p>
             <a:pPr lvl="0"/>
             <a:r>
-              <a:rPr lang="en-US" smtClean="0"/>
+              <a:rPr lang="en-US"/>
               <a:t>Click to edit Master text styles</a:t>
             </a:r>
           </a:p>
@@ -3367,7 +3174,7 @@
           <a:p>
             <a:fld id="{5BCAD085-E8A6-8845-BD4E-CB4CCA059FC4}" type="datetimeFigureOut">
               <a:rPr lang="en-US" smtClean="0"/>
-              <a:t>1/27/13</a:t>
+              <a:t>2026-05-31</a:t>
             </a:fld>
             <a:endParaRPr lang="en-US"/>
           </a:p>
@@ -3470,10 +3277,9 @@
           </a:lstStyle>
           <a:p>
             <a:r>
-              <a:rPr lang="en-US" smtClean="0"/>
+              <a:rPr lang="en-US"/>
               <a:t>Click to edit Master title style</a:t>
             </a:r>
-            <a:endParaRPr lang="en-US"/>
           </a:p>
         </p:txBody>
       </p:sp>
@@ -3597,7 +3403,7 @@
           <a:p>
             <a:pPr lvl="0"/>
             <a:r>
-              <a:rPr lang="en-US" smtClean="0"/>
+              <a:rPr lang="en-US"/>
               <a:t>Click to edit Master text styles</a:t>
             </a:r>
           </a:p>
@@ -3620,7 +3426,7 @@
           <a:p>
             <a:fld id="{5BCAD085-E8A6-8845-BD4E-CB4CCA059FC4}" type="datetimeFigureOut">
               <a:rPr lang="en-US" smtClean="0"/>
-              <a:t>1/27/13</a:t>
+              <a:t>2026-05-31</a:t>
             </a:fld>
             <a:endParaRPr lang="en-US"/>
           </a:p>
@@ -3729,10 +3535,9 @@
           <a:lstStyle/>
           <a:p>
             <a:r>
-              <a:rPr lang="en-US" smtClean="0"/>
+              <a:rPr lang="en-US"/>
               <a:t>Click to edit Master title style</a:t>
             </a:r>
-            <a:endParaRPr lang="en-US"/>
           </a:p>
         </p:txBody>
       </p:sp>
@@ -3763,38 +3568,37 @@
           <a:p>
             <a:pPr lvl="0"/>
             <a:r>
-              <a:rPr lang="en-US" smtClean="0"/>
+              <a:rPr lang="en-US"/>
               <a:t>Click to edit Master text styles</a:t>
             </a:r>
           </a:p>
           <a:p>
             <a:pPr lvl="1"/>
             <a:r>
-              <a:rPr lang="en-US" smtClean="0"/>
+              <a:rPr lang="en-US"/>
               <a:t>Second level</a:t>
             </a:r>
           </a:p>
           <a:p>
             <a:pPr lvl="2"/>
             <a:r>
-              <a:rPr lang="en-US" smtClean="0"/>
+              <a:rPr lang="en-US"/>
               <a:t>Third level</a:t>
             </a:r>
           </a:p>
           <a:p>
             <a:pPr lvl="3"/>
             <a:r>
-              <a:rPr lang="en-US" smtClean="0"/>
+              <a:rPr lang="en-US"/>
               <a:t>Fourth level</a:t>
             </a:r>
           </a:p>
           <a:p>
             <a:pPr lvl="4"/>
             <a:r>
-              <a:rPr lang="en-US" smtClean="0"/>
+              <a:rPr lang="en-US"/>
               <a:t>Fifth level</a:t>
             </a:r>
-            <a:endParaRPr lang="en-US"/>
           </a:p>
         </p:txBody>
       </p:sp>
@@ -3833,7 +3637,7 @@
           <a:p>
             <a:fld id="{5BCAD085-E8A6-8845-BD4E-CB4CCA059FC4}" type="datetimeFigureOut">
               <a:rPr lang="en-US" smtClean="0"/>
-              <a:t>1/27/13</a:t>
+              <a:t>2026-05-31</a:t>
             </a:fld>
             <a:endParaRPr lang="en-US"/>
           </a:p>
@@ -4192,7 +3996,7 @@
 </file>
 
 <file path=ppt/slides/slide1.xml><?xml version="1.0" encoding="utf-8"?>
-<p:sld xmlns:a="http://schemas.openxmlformats.org/drawingml/2006/main" xmlns:p="http://schemas.openxmlformats.org/presentationml/2006/main" xmlns:r="http://schemas.openxmlformats.org/officeDocument/2006/relationships">
+<p:sld xmlns:a="http://schemas.openxmlformats.org/drawingml/2006/main" xmlns:r="http://schemas.openxmlformats.org/officeDocument/2006/relationships" xmlns:p="http://schemas.openxmlformats.org/presentationml/2006/main">
   <p:cSld>
     <p:bg>
       <p:bgPr>
@@ -4208,7 +4012,14 @@
         <p:cNvGrpSpPr/>
         <p:nvPr/>
       </p:nvGrpSpPr>
-      <p:grpSpPr/>
+      <p:grpSpPr>
+        <a:xfrm>
+          <a:off x="0" y="0"/>
+          <a:ext cx="0" cy="0"/>
+          <a:chOff x="0" y="0"/>
+          <a:chExt cx="0" cy="0"/>
+        </a:xfrm>
+      </p:grpSpPr>
       <p:sp>
         <p:nvSpPr>
           <p:cNvPr id="2" name="TextBox 1"/>
@@ -4430,7 +4241,7 @@
 </file>
 
 <file path=ppt/slides/slide10.xml><?xml version="1.0" encoding="utf-8"?>
-<p:sld xmlns:a="http://schemas.openxmlformats.org/drawingml/2006/main" xmlns:p="http://schemas.openxmlformats.org/presentationml/2006/main" xmlns:r="http://schemas.openxmlformats.org/officeDocument/2006/relationships">
+<p:sld xmlns:a="http://schemas.openxmlformats.org/drawingml/2006/main" xmlns:r="http://schemas.openxmlformats.org/officeDocument/2006/relationships" xmlns:p="http://schemas.openxmlformats.org/presentationml/2006/main">
   <p:cSld>
     <p:bg>
       <p:bgPr>
@@ -4446,7 +4257,14 @@
         <p:cNvGrpSpPr/>
         <p:nvPr/>
       </p:nvGrpSpPr>
-      <p:grpSpPr/>
+      <p:grpSpPr>
+        <a:xfrm>
+          <a:off x="0" y="0"/>
+          <a:ext cx="0" cy="0"/>
+          <a:chOff x="0" y="0"/>
+          <a:chExt cx="0" cy="0"/>
+        </a:xfrm>
+      </p:grpSpPr>
       <p:sp>
         <p:nvSpPr>
           <p:cNvPr id="2" name="TextBox 1"/>
@@ -4808,7 +4626,7 @@
 </file>
 
 <file path=ppt/slides/slide11.xml><?xml version="1.0" encoding="utf-8"?>
-<p:sld xmlns:a="http://schemas.openxmlformats.org/drawingml/2006/main" xmlns:p="http://schemas.openxmlformats.org/presentationml/2006/main" xmlns:r="http://schemas.openxmlformats.org/officeDocument/2006/relationships">
+<p:sld xmlns:a="http://schemas.openxmlformats.org/drawingml/2006/main" xmlns:r="http://schemas.openxmlformats.org/officeDocument/2006/relationships" xmlns:p="http://schemas.openxmlformats.org/presentationml/2006/main">
   <p:cSld>
     <p:bg>
       <p:bgPr>
@@ -4824,7 +4642,14 @@
         <p:cNvGrpSpPr/>
         <p:nvPr/>
       </p:nvGrpSpPr>
-      <p:grpSpPr/>
+      <p:grpSpPr>
+        <a:xfrm>
+          <a:off x="0" y="0"/>
+          <a:ext cx="0" cy="0"/>
+          <a:chOff x="0" y="0"/>
+          <a:chExt cx="0" cy="0"/>
+        </a:xfrm>
+      </p:grpSpPr>
       <p:sp>
         <p:nvSpPr>
           <p:cNvPr id="2" name="TextBox 1"/>
@@ -5213,7 +5038,7 @@
 </file>
 
 <file path=ppt/slides/slide12.xml><?xml version="1.0" encoding="utf-8"?>
-<p:sld xmlns:a="http://schemas.openxmlformats.org/drawingml/2006/main" xmlns:p="http://schemas.openxmlformats.org/presentationml/2006/main" xmlns:r="http://schemas.openxmlformats.org/officeDocument/2006/relationships">
+<p:sld xmlns:a="http://schemas.openxmlformats.org/drawingml/2006/main" xmlns:r="http://schemas.openxmlformats.org/officeDocument/2006/relationships" xmlns:p="http://schemas.openxmlformats.org/presentationml/2006/main">
   <p:cSld>
     <p:bg>
       <p:bgPr>
@@ -5229,7 +5054,14 @@
         <p:cNvGrpSpPr/>
         <p:nvPr/>
       </p:nvGrpSpPr>
-      <p:grpSpPr/>
+      <p:grpSpPr>
+        <a:xfrm>
+          <a:off x="0" y="0"/>
+          <a:ext cx="0" cy="0"/>
+          <a:chOff x="0" y="0"/>
+          <a:chExt cx="0" cy="0"/>
+        </a:xfrm>
+      </p:grpSpPr>
       <p:sp>
         <p:nvSpPr>
           <p:cNvPr id="2" name="TextBox 1"/>
@@ -5539,7 +5371,7 @@
 </file>
 
 <file path=ppt/slides/slide13.xml><?xml version="1.0" encoding="utf-8"?>
-<p:sld xmlns:a="http://schemas.openxmlformats.org/drawingml/2006/main" xmlns:p="http://schemas.openxmlformats.org/presentationml/2006/main" xmlns:r="http://schemas.openxmlformats.org/officeDocument/2006/relationships">
+<p:sld xmlns:a="http://schemas.openxmlformats.org/drawingml/2006/main" xmlns:r="http://schemas.openxmlformats.org/officeDocument/2006/relationships" xmlns:p="http://schemas.openxmlformats.org/presentationml/2006/main">
   <p:cSld>
     <p:bg>
       <p:bgPr>
@@ -5555,7 +5387,14 @@
         <p:cNvGrpSpPr/>
         <p:nvPr/>
       </p:nvGrpSpPr>
-      <p:grpSpPr/>
+      <p:grpSpPr>
+        <a:xfrm>
+          <a:off x="0" y="0"/>
+          <a:ext cx="0" cy="0"/>
+          <a:chOff x="0" y="0"/>
+          <a:chExt cx="0" cy="0"/>
+        </a:xfrm>
+      </p:grpSpPr>
       <p:sp>
         <p:nvSpPr>
           <p:cNvPr id="2" name="TextBox 1"/>
@@ -5865,7 +5704,7 @@
 </file>
 
 <file path=ppt/slides/slide14.xml><?xml version="1.0" encoding="utf-8"?>
-<p:sld xmlns:a="http://schemas.openxmlformats.org/drawingml/2006/main" xmlns:p="http://schemas.openxmlformats.org/presentationml/2006/main" xmlns:r="http://schemas.openxmlformats.org/officeDocument/2006/relationships">
+<p:sld xmlns:a="http://schemas.openxmlformats.org/drawingml/2006/main" xmlns:r="http://schemas.openxmlformats.org/officeDocument/2006/relationships" xmlns:p="http://schemas.openxmlformats.org/presentationml/2006/main">
   <p:cSld>
     <p:bg>
       <p:bgPr>
@@ -5881,7 +5720,14 @@
         <p:cNvGrpSpPr/>
         <p:nvPr/>
       </p:nvGrpSpPr>
-      <p:grpSpPr/>
+      <p:grpSpPr>
+        <a:xfrm>
+          <a:off x="0" y="0"/>
+          <a:ext cx="0" cy="0"/>
+          <a:chOff x="0" y="0"/>
+          <a:chExt cx="0" cy="0"/>
+        </a:xfrm>
+      </p:grpSpPr>
       <p:sp>
         <p:nvSpPr>
           <p:cNvPr id="2" name="TextBox 1"/>
@@ -6191,7 +6037,7 @@
 </file>
 
 <file path=ppt/slides/slide15.xml><?xml version="1.0" encoding="utf-8"?>
-<p:sld xmlns:a="http://schemas.openxmlformats.org/drawingml/2006/main" xmlns:p="http://schemas.openxmlformats.org/presentationml/2006/main" xmlns:r="http://schemas.openxmlformats.org/officeDocument/2006/relationships">
+<p:sld xmlns:a="http://schemas.openxmlformats.org/drawingml/2006/main" xmlns:r="http://schemas.openxmlformats.org/officeDocument/2006/relationships" xmlns:p="http://schemas.openxmlformats.org/presentationml/2006/main">
   <p:cSld>
     <p:bg>
       <p:bgPr>
@@ -6207,7 +6053,14 @@
         <p:cNvGrpSpPr/>
         <p:nvPr/>
       </p:nvGrpSpPr>
-      <p:grpSpPr/>
+      <p:grpSpPr>
+        <a:xfrm>
+          <a:off x="0" y="0"/>
+          <a:ext cx="0" cy="0"/>
+          <a:chOff x="0" y="0"/>
+          <a:chExt cx="0" cy="0"/>
+        </a:xfrm>
+      </p:grpSpPr>
       <p:sp>
         <p:nvSpPr>
           <p:cNvPr id="2" name="TextBox 1"/>
@@ -6494,7 +6347,7 @@
 </file>
 
 <file path=ppt/slides/slide16.xml><?xml version="1.0" encoding="utf-8"?>
-<p:sld xmlns:a="http://schemas.openxmlformats.org/drawingml/2006/main" xmlns:p="http://schemas.openxmlformats.org/presentationml/2006/main" xmlns:r="http://schemas.openxmlformats.org/officeDocument/2006/relationships">
+<p:sld xmlns:a="http://schemas.openxmlformats.org/drawingml/2006/main" xmlns:r="http://schemas.openxmlformats.org/officeDocument/2006/relationships" xmlns:p="http://schemas.openxmlformats.org/presentationml/2006/main">
   <p:cSld>
     <p:bg>
       <p:bgPr>
@@ -6510,7 +6363,14 @@
         <p:cNvGrpSpPr/>
         <p:nvPr/>
       </p:nvGrpSpPr>
-      <p:grpSpPr/>
+      <p:grpSpPr>
+        <a:xfrm>
+          <a:off x="0" y="0"/>
+          <a:ext cx="0" cy="0"/>
+          <a:chOff x="0" y="0"/>
+          <a:chExt cx="0" cy="0"/>
+        </a:xfrm>
+      </p:grpSpPr>
       <p:sp>
         <p:nvSpPr>
           <p:cNvPr id="2" name="TextBox 1"/>
@@ -6820,7 +6680,7 @@
 </file>
 
 <file path=ppt/slides/slide17.xml><?xml version="1.0" encoding="utf-8"?>
-<p:sld xmlns:a="http://schemas.openxmlformats.org/drawingml/2006/main" xmlns:p="http://schemas.openxmlformats.org/presentationml/2006/main" xmlns:r="http://schemas.openxmlformats.org/officeDocument/2006/relationships">
+<p:sld xmlns:a="http://schemas.openxmlformats.org/drawingml/2006/main" xmlns:r="http://schemas.openxmlformats.org/officeDocument/2006/relationships" xmlns:p="http://schemas.openxmlformats.org/presentationml/2006/main">
   <p:cSld>
     <p:bg>
       <p:bgPr>
@@ -6836,7 +6696,14 @@
         <p:cNvGrpSpPr/>
         <p:nvPr/>
       </p:nvGrpSpPr>
-      <p:grpSpPr/>
+      <p:grpSpPr>
+        <a:xfrm>
+          <a:off x="0" y="0"/>
+          <a:ext cx="0" cy="0"/>
+          <a:chOff x="0" y="0"/>
+          <a:chExt cx="0" cy="0"/>
+        </a:xfrm>
+      </p:grpSpPr>
       <p:sp>
         <p:nvSpPr>
           <p:cNvPr id="2" name="TextBox 1"/>
@@ -7187,7 +7054,7 @@
 </file>
 
 <file path=ppt/slides/slide2.xml><?xml version="1.0" encoding="utf-8"?>
-<p:sld xmlns:a="http://schemas.openxmlformats.org/drawingml/2006/main" xmlns:p="http://schemas.openxmlformats.org/presentationml/2006/main" xmlns:r="http://schemas.openxmlformats.org/officeDocument/2006/relationships">
+<p:sld xmlns:a="http://schemas.openxmlformats.org/drawingml/2006/main" xmlns:r="http://schemas.openxmlformats.org/officeDocument/2006/relationships" xmlns:p="http://schemas.openxmlformats.org/presentationml/2006/main">
   <p:cSld>
     <p:bg>
       <p:bgPr>
@@ -7203,7 +7070,14 @@
         <p:cNvGrpSpPr/>
         <p:nvPr/>
       </p:nvGrpSpPr>
-      <p:grpSpPr/>
+      <p:grpSpPr>
+        <a:xfrm>
+          <a:off x="0" y="0"/>
+          <a:ext cx="0" cy="0"/>
+          <a:chOff x="0" y="0"/>
+          <a:chExt cx="0" cy="0"/>
+        </a:xfrm>
+      </p:grpSpPr>
       <p:sp>
         <p:nvSpPr>
           <p:cNvPr id="2" name="TextBox 1"/>
@@ -7465,7 +7339,7 @@
 </file>
 
 <file path=ppt/slides/slide3.xml><?xml version="1.0" encoding="utf-8"?>
-<p:sld xmlns:a="http://schemas.openxmlformats.org/drawingml/2006/main" xmlns:p="http://schemas.openxmlformats.org/presentationml/2006/main" xmlns:r="http://schemas.openxmlformats.org/officeDocument/2006/relationships">
+<p:sld xmlns:a="http://schemas.openxmlformats.org/drawingml/2006/main" xmlns:r="http://schemas.openxmlformats.org/officeDocument/2006/relationships" xmlns:p="http://schemas.openxmlformats.org/presentationml/2006/main">
   <p:cSld>
     <p:bg>
       <p:bgPr>
@@ -7481,7 +7355,14 @@
         <p:cNvGrpSpPr/>
         <p:nvPr/>
       </p:nvGrpSpPr>
-      <p:grpSpPr/>
+      <p:grpSpPr>
+        <a:xfrm>
+          <a:off x="0" y="0"/>
+          <a:ext cx="0" cy="0"/>
+          <a:chOff x="0" y="0"/>
+          <a:chExt cx="0" cy="0"/>
+        </a:xfrm>
+      </p:grpSpPr>
       <p:sp>
         <p:nvSpPr>
           <p:cNvPr id="2" name="TextBox 1"/>
@@ -7842,7 +7723,7 @@
 </file>
 
 <file path=ppt/slides/slide4.xml><?xml version="1.0" encoding="utf-8"?>
-<p:sld xmlns:a="http://schemas.openxmlformats.org/drawingml/2006/main" xmlns:p="http://schemas.openxmlformats.org/presentationml/2006/main" xmlns:r="http://schemas.openxmlformats.org/officeDocument/2006/relationships">
+<p:sld xmlns:a="http://schemas.openxmlformats.org/drawingml/2006/main" xmlns:r="http://schemas.openxmlformats.org/officeDocument/2006/relationships" xmlns:p="http://schemas.openxmlformats.org/presentationml/2006/main">
   <p:cSld>
     <p:bg>
       <p:bgPr>
@@ -7858,7 +7739,14 @@
         <p:cNvGrpSpPr/>
         <p:nvPr/>
       </p:nvGrpSpPr>
-      <p:grpSpPr/>
+      <p:grpSpPr>
+        <a:xfrm>
+          <a:off x="0" y="0"/>
+          <a:ext cx="0" cy="0"/>
+          <a:chOff x="0" y="0"/>
+          <a:chExt cx="0" cy="0"/>
+        </a:xfrm>
+      </p:grpSpPr>
       <p:sp>
         <p:nvSpPr>
           <p:cNvPr id="2" name="TextBox 1"/>
@@ -8063,7 +7951,7 @@
 </file>
 
 <file path=ppt/slides/slide5.xml><?xml version="1.0" encoding="utf-8"?>
-<p:sld xmlns:a="http://schemas.openxmlformats.org/drawingml/2006/main" xmlns:p="http://schemas.openxmlformats.org/presentationml/2006/main" xmlns:r="http://schemas.openxmlformats.org/officeDocument/2006/relationships">
+<p:sld xmlns:a="http://schemas.openxmlformats.org/drawingml/2006/main" xmlns:r="http://schemas.openxmlformats.org/officeDocument/2006/relationships" xmlns:p="http://schemas.openxmlformats.org/presentationml/2006/main">
   <p:cSld>
     <p:bg>
       <p:bgPr>
@@ -8079,7 +7967,14 @@
         <p:cNvGrpSpPr/>
         <p:nvPr/>
       </p:nvGrpSpPr>
-      <p:grpSpPr/>
+      <p:grpSpPr>
+        <a:xfrm>
+          <a:off x="0" y="0"/>
+          <a:ext cx="0" cy="0"/>
+          <a:chOff x="0" y="0"/>
+          <a:chExt cx="0" cy="0"/>
+        </a:xfrm>
+      </p:grpSpPr>
       <p:sp>
         <p:nvSpPr>
           <p:cNvPr id="2" name="TextBox 1"/>
@@ -8370,7 +8265,7 @@
 </file>
 
 <file path=ppt/slides/slide6.xml><?xml version="1.0" encoding="utf-8"?>
-<p:sld xmlns:a="http://schemas.openxmlformats.org/drawingml/2006/main" xmlns:p="http://schemas.openxmlformats.org/presentationml/2006/main" xmlns:r="http://schemas.openxmlformats.org/officeDocument/2006/relationships">
+<p:sld xmlns:a="http://schemas.openxmlformats.org/drawingml/2006/main" xmlns:r="http://schemas.openxmlformats.org/officeDocument/2006/relationships" xmlns:p="http://schemas.openxmlformats.org/presentationml/2006/main">
   <p:cSld>
     <p:bg>
       <p:bgPr>
@@ -8386,7 +8281,14 @@
         <p:cNvGrpSpPr/>
         <p:nvPr/>
       </p:nvGrpSpPr>
-      <p:grpSpPr/>
+      <p:grpSpPr>
+        <a:xfrm>
+          <a:off x="0" y="0"/>
+          <a:ext cx="0" cy="0"/>
+          <a:chOff x="0" y="0"/>
+          <a:chExt cx="0" cy="0"/>
+        </a:xfrm>
+      </p:grpSpPr>
       <p:sp>
         <p:nvSpPr>
           <p:cNvPr id="2" name="TextBox 1"/>
@@ -8751,7 +8653,7 @@
 </file>
 
 <file path=ppt/slides/slide7.xml><?xml version="1.0" encoding="utf-8"?>
-<p:sld xmlns:a="http://schemas.openxmlformats.org/drawingml/2006/main" xmlns:p="http://schemas.openxmlformats.org/presentationml/2006/main" xmlns:r="http://schemas.openxmlformats.org/officeDocument/2006/relationships">
+<p:sld xmlns:a="http://schemas.openxmlformats.org/drawingml/2006/main" xmlns:r="http://schemas.openxmlformats.org/officeDocument/2006/relationships" xmlns:p="http://schemas.openxmlformats.org/presentationml/2006/main">
   <p:cSld>
     <p:bg>
       <p:bgPr>
@@ -8767,7 +8669,14 @@
         <p:cNvGrpSpPr/>
         <p:nvPr/>
       </p:nvGrpSpPr>
-      <p:grpSpPr/>
+      <p:grpSpPr>
+        <a:xfrm>
+          <a:off x="0" y="0"/>
+          <a:ext cx="0" cy="0"/>
+          <a:chOff x="0" y="0"/>
+          <a:chExt cx="0" cy="0"/>
+        </a:xfrm>
+      </p:grpSpPr>
       <p:sp>
         <p:nvSpPr>
           <p:cNvPr id="2" name="TextBox 1"/>
@@ -9091,7 +9000,7 @@
 </file>
 
 <file path=ppt/slides/slide8.xml><?xml version="1.0" encoding="utf-8"?>
-<p:sld xmlns:a="http://schemas.openxmlformats.org/drawingml/2006/main" xmlns:p="http://schemas.openxmlformats.org/presentationml/2006/main" xmlns:r="http://schemas.openxmlformats.org/officeDocument/2006/relationships">
+<p:sld xmlns:a="http://schemas.openxmlformats.org/drawingml/2006/main" xmlns:r="http://schemas.openxmlformats.org/officeDocument/2006/relationships" xmlns:p="http://schemas.openxmlformats.org/presentationml/2006/main">
   <p:cSld>
     <p:bg>
       <p:bgPr>
@@ -9107,7 +9016,14 @@
         <p:cNvGrpSpPr/>
         <p:nvPr/>
       </p:nvGrpSpPr>
-      <p:grpSpPr/>
+      <p:grpSpPr>
+        <a:xfrm>
+          <a:off x="0" y="0"/>
+          <a:ext cx="0" cy="0"/>
+          <a:chOff x="0" y="0"/>
+          <a:chExt cx="0" cy="0"/>
+        </a:xfrm>
+      </p:grpSpPr>
       <p:sp>
         <p:nvSpPr>
           <p:cNvPr id="2" name="TextBox 1"/>
@@ -9234,7 +9150,7 @@
           </a:fontRef>
         </p:style>
         <p:txBody>
-          <a:bodyPr rtlCol="0" anchor="ctr" wrap="square"/>
+          <a:bodyPr wrap="square" rtlCol="0" anchor="ctr"/>
           <a:lstStyle/>
           <a:p>
             <a:pPr algn="ctr">
@@ -9408,16 +9324,189 @@
           </a:p>
         </p:txBody>
       </p:sp>
+      <p:pic>
+        <p:nvPicPr>
+          <p:cNvPr id="8" name="AI Bank Run Sandbox - 31 May 2026">
+            <a:hlinkClick r:id="" action="ppaction://media"/>
+            <a:extLst>
+              <a:ext uri="{FF2B5EF4-FFF2-40B4-BE49-F238E27FC236}">
+                <a16:creationId xmlns:a16="http://schemas.microsoft.com/office/drawing/2014/main" id="{D06512F9-48A2-1893-A228-04C88AC0B4BE}"/>
+              </a:ext>
+            </a:extLst>
+          </p:cNvPr>
+          <p:cNvPicPr>
+            <a:picLocks noChangeAspect="1"/>
+          </p:cNvPicPr>
+          <p:nvPr>
+            <a:videoFile r:link="rId2"/>
+            <p:extLst>
+              <p:ext uri="{DAA4B4D4-6D71-4841-9C94-3DE7FCFB9230}">
+                <p14:media xmlns:p14="http://schemas.microsoft.com/office/powerpoint/2010/main" r:embed="rId1"/>
+              </p:ext>
+            </p:extLst>
+          </p:nvPr>
+        </p:nvPicPr>
+        <p:blipFill>
+          <a:blip r:embed="rId5"/>
+          <a:stretch>
+            <a:fillRect/>
+          </a:stretch>
+        </p:blipFill>
+        <p:spPr>
+          <a:xfrm>
+            <a:off x="3143026" y="1710802"/>
+            <a:ext cx="5905948" cy="3322096"/>
+          </a:xfrm>
+          <a:prstGeom prst="rect">
+            <a:avLst/>
+          </a:prstGeom>
+        </p:spPr>
+      </p:pic>
     </p:spTree>
   </p:cSld>
   <p:clrMapOvr>
     <a:masterClrMapping/>
   </p:clrMapOvr>
+  <p:timing>
+    <p:tnLst>
+      <p:par>
+        <p:cTn id="1" dur="indefinite" restart="never" nodeType="tmRoot">
+          <p:childTnLst>
+            <p:seq concurrent="1" nextAc="seek">
+              <p:cTn id="2" dur="indefinite" nodeType="mainSeq">
+                <p:childTnLst>
+                  <p:par>
+                    <p:cTn id="3" fill="hold">
+                      <p:stCondLst>
+                        <p:cond delay="indefinite"/>
+                      </p:stCondLst>
+                      <p:childTnLst>
+                        <p:par>
+                          <p:cTn id="4" fill="hold">
+                            <p:stCondLst>
+                              <p:cond delay="0"/>
+                            </p:stCondLst>
+                            <p:childTnLst>
+                              <p:par>
+                                <p:cTn id="5" presetID="1" presetClass="mediacall" presetSubtype="0" fill="hold" nodeType="clickEffect">
+                                  <p:stCondLst>
+                                    <p:cond delay="0"/>
+                                  </p:stCondLst>
+                                  <p:childTnLst>
+                                    <p:cmd type="call" cmd="playFrom(0.0)">
+                                      <p:cBhvr>
+                                        <p:cTn id="6" dur="43824" fill="hold"/>
+                                        <p:tgtEl>
+                                          <p:spTgt spid="8"/>
+                                        </p:tgtEl>
+                                      </p:cBhvr>
+                                    </p:cmd>
+                                  </p:childTnLst>
+                                </p:cTn>
+                              </p:par>
+                            </p:childTnLst>
+                          </p:cTn>
+                        </p:par>
+                      </p:childTnLst>
+                    </p:cTn>
+                  </p:par>
+                </p:childTnLst>
+              </p:cTn>
+              <p:prevCondLst>
+                <p:cond evt="onPrev" delay="0">
+                  <p:tgtEl>
+                    <p:sldTgt/>
+                  </p:tgtEl>
+                </p:cond>
+              </p:prevCondLst>
+              <p:nextCondLst>
+                <p:cond evt="onNext" delay="0">
+                  <p:tgtEl>
+                    <p:sldTgt/>
+                  </p:tgtEl>
+                </p:cond>
+              </p:nextCondLst>
+            </p:seq>
+            <p:video fullScrn="1">
+              <p:cMediaNode vol="80000">
+                <p:cTn id="7" fill="hold" display="0">
+                  <p:stCondLst>
+                    <p:cond delay="indefinite"/>
+                  </p:stCondLst>
+                </p:cTn>
+                <p:tgtEl>
+                  <p:spTgt spid="8"/>
+                </p:tgtEl>
+              </p:cMediaNode>
+            </p:video>
+            <p:seq concurrent="1" nextAc="seek">
+              <p:cTn id="8" restart="whenNotActive" fill="hold" evtFilter="cancelBubble" nodeType="interactiveSeq">
+                <p:stCondLst>
+                  <p:cond evt="onClick" delay="0">
+                    <p:tgtEl>
+                      <p:spTgt spid="8"/>
+                    </p:tgtEl>
+                  </p:cond>
+                </p:stCondLst>
+                <p:endSync evt="end" delay="0">
+                  <p:rtn val="all"/>
+                </p:endSync>
+                <p:childTnLst>
+                  <p:par>
+                    <p:cTn id="9" fill="hold">
+                      <p:stCondLst>
+                        <p:cond delay="0"/>
+                      </p:stCondLst>
+                      <p:childTnLst>
+                        <p:par>
+                          <p:cTn id="10" fill="hold">
+                            <p:stCondLst>
+                              <p:cond delay="0"/>
+                            </p:stCondLst>
+                            <p:childTnLst>
+                              <p:par>
+                                <p:cTn id="11" presetID="2" presetClass="mediacall" presetSubtype="0" fill="hold" nodeType="clickEffect">
+                                  <p:stCondLst>
+                                    <p:cond delay="0"/>
+                                  </p:stCondLst>
+                                  <p:childTnLst>
+                                    <p:cmd type="call" cmd="togglePause">
+                                      <p:cBhvr>
+                                        <p:cTn id="12" dur="1" fill="hold"/>
+                                        <p:tgtEl>
+                                          <p:spTgt spid="8"/>
+                                        </p:tgtEl>
+                                      </p:cBhvr>
+                                    </p:cmd>
+                                  </p:childTnLst>
+                                </p:cTn>
+                              </p:par>
+                            </p:childTnLst>
+                          </p:cTn>
+                        </p:par>
+                      </p:childTnLst>
+                    </p:cTn>
+                  </p:par>
+                </p:childTnLst>
+              </p:cTn>
+              <p:nextCondLst>
+                <p:cond evt="onClick" delay="0">
+                  <p:tgtEl>
+                    <p:spTgt spid="8"/>
+                  </p:tgtEl>
+                </p:cond>
+              </p:nextCondLst>
+            </p:seq>
+          </p:childTnLst>
+        </p:cTn>
+      </p:par>
+    </p:tnLst>
+  </p:timing>
 </p:sld>
 </file>
 
 <file path=ppt/slides/slide9.xml><?xml version="1.0" encoding="utf-8"?>
-<p:sld xmlns:a="http://schemas.openxmlformats.org/drawingml/2006/main" xmlns:p="http://schemas.openxmlformats.org/presentationml/2006/main" xmlns:r="http://schemas.openxmlformats.org/officeDocument/2006/relationships">
+<p:sld xmlns:a="http://schemas.openxmlformats.org/drawingml/2006/main" xmlns:r="http://schemas.openxmlformats.org/officeDocument/2006/relationships" xmlns:p="http://schemas.openxmlformats.org/presentationml/2006/main">
   <p:cSld>
     <p:bg>
       <p:bgPr>
@@ -9433,7 +9522,14 @@
         <p:cNvGrpSpPr/>
         <p:nvPr/>
       </p:nvGrpSpPr>
-      <p:grpSpPr/>
+      <p:grpSpPr>
+        <a:xfrm>
+          <a:off x="0" y="0"/>
+          <a:ext cx="0" cy="0"/>
+          <a:chOff x="0" y="0"/>
+          <a:chExt cx="0" cy="0"/>
+        </a:xfrm>
+      </p:grpSpPr>
       <p:sp>
         <p:nvSpPr>
           <p:cNvPr id="2" name="TextBox 1"/>
@@ -9828,44 +9924,44 @@
         <a:sysClr val="window" lastClr="FFFFFF"/>
       </a:lt1>
       <a:dk2>
-        <a:srgbClr val="1F497D"/>
+        <a:srgbClr val="0E2841"/>
       </a:dk2>
       <a:lt2>
-        <a:srgbClr val="EEECE1"/>
+        <a:srgbClr val="E8E8E8"/>
       </a:lt2>
       <a:accent1>
-        <a:srgbClr val="4F81BD"/>
+        <a:srgbClr val="156082"/>
       </a:accent1>
       <a:accent2>
-        <a:srgbClr val="C0504D"/>
+        <a:srgbClr val="E97132"/>
       </a:accent2>
       <a:accent3>
-        <a:srgbClr val="9BBB59"/>
+        <a:srgbClr val="196B24"/>
       </a:accent3>
       <a:accent4>
-        <a:srgbClr val="8064A2"/>
+        <a:srgbClr val="0F9ED5"/>
       </a:accent4>
       <a:accent5>
-        <a:srgbClr val="4BACC6"/>
+        <a:srgbClr val="A02B93"/>
       </a:accent5>
       <a:accent6>
-        <a:srgbClr val="F79646"/>
+        <a:srgbClr val="4EA72E"/>
       </a:accent6>
       <a:hlink>
-        <a:srgbClr val="0000FF"/>
+        <a:srgbClr val="467886"/>
       </a:hlink>
       <a:folHlink>
-        <a:srgbClr val="800080"/>
+        <a:srgbClr val="96607D"/>
       </a:folHlink>
     </a:clrScheme>
     <a:fontScheme name="Office">
       <a:majorFont>
-        <a:latin typeface="Calibri"/>
+        <a:latin typeface="Aptos Display" panose="02110004020202020204"/>
         <a:ea typeface=""/>
         <a:cs typeface=""/>
-        <a:font script="Jpan" typeface="ＭＳ Ｐゴシック"/>
+        <a:font script="Jpan" typeface="游ゴシック Light"/>
         <a:font script="Hang" typeface="맑은 고딕"/>
-        <a:font script="Hans" typeface="宋体"/>
+        <a:font script="Hans" typeface="等线 Light"/>
         <a:font script="Hant" typeface="新細明體"/>
         <a:font script="Arab" typeface="Times New Roman"/>
         <a:font script="Hebr" typeface="Times New Roman"/>
@@ -9893,14 +9989,31 @@
         <a:font script="Viet" typeface="Times New Roman"/>
         <a:font script="Uigh" typeface="Microsoft Uighur"/>
         <a:font script="Geor" typeface="Sylfaen"/>
+        <a:font script="Armn" typeface="Arial"/>
+        <a:font script="Bugi" typeface="Leelawadee UI"/>
+        <a:font script="Bopo" typeface="Microsoft JhengHei"/>
+        <a:font script="Java" typeface="Javanese Text"/>
+        <a:font script="Lisu" typeface="Segoe UI"/>
+        <a:font script="Mymr" typeface="Myanmar Text"/>
+        <a:font script="Nkoo" typeface="Ebrima"/>
+        <a:font script="Olck" typeface="Nirmala UI"/>
+        <a:font script="Osma" typeface="Ebrima"/>
+        <a:font script="Phag" typeface="Phagspa"/>
+        <a:font script="Syrn" typeface="Estrangelo Edessa"/>
+        <a:font script="Syrj" typeface="Estrangelo Edessa"/>
+        <a:font script="Syre" typeface="Estrangelo Edessa"/>
+        <a:font script="Sora" typeface="Nirmala UI"/>
+        <a:font script="Tale" typeface="Microsoft Tai Le"/>
+        <a:font script="Talu" typeface="Microsoft New Tai Lue"/>
+        <a:font script="Tfng" typeface="Ebrima"/>
       </a:majorFont>
       <a:minorFont>
-        <a:latin typeface="Calibri"/>
+        <a:latin typeface="Aptos" panose="02110004020202020204"/>
         <a:ea typeface=""/>
         <a:cs typeface=""/>
-        <a:font script="Jpan" typeface="ＭＳ Ｐゴシック"/>
+        <a:font script="Jpan" typeface="游ゴシック"/>
         <a:font script="Hang" typeface="맑은 고딕"/>
-        <a:font script="Hans" typeface="宋体"/>
+        <a:font script="Hans" typeface="等线"/>
         <a:font script="Hant" typeface="新細明體"/>
         <a:font script="Arab" typeface="Arial"/>
         <a:font script="Hebr" typeface="Arial"/>
@@ -9928,6 +10041,23 @@
         <a:font script="Viet" typeface="Arial"/>
         <a:font script="Uigh" typeface="Microsoft Uighur"/>
         <a:font script="Geor" typeface="Sylfaen"/>
+        <a:font script="Armn" typeface="Arial"/>
+        <a:font script="Bugi" typeface="Leelawadee UI"/>
+        <a:font script="Bopo" typeface="Microsoft JhengHei"/>
+        <a:font script="Java" typeface="Javanese Text"/>
+        <a:font script="Lisu" typeface="Segoe UI"/>
+        <a:font script="Mymr" typeface="Myanmar Text"/>
+        <a:font script="Nkoo" typeface="Ebrima"/>
+        <a:font script="Olck" typeface="Nirmala UI"/>
+        <a:font script="Osma" typeface="Ebrima"/>
+        <a:font script="Phag" typeface="Phagspa"/>
+        <a:font script="Syrn" typeface="Estrangelo Edessa"/>
+        <a:font script="Syrj" typeface="Estrangelo Edessa"/>
+        <a:font script="Syre" typeface="Estrangelo Edessa"/>
+        <a:font script="Sora" typeface="Nirmala UI"/>
+        <a:font script="Tale" typeface="Microsoft Tai Le"/>
+        <a:font script="Talu" typeface="Microsoft New Tai Lue"/>
+        <a:font script="Tfng" typeface="Ebrima"/>
       </a:minorFont>
     </a:fontScheme>
     <a:fmtScheme name="Office">
@@ -9939,180 +10069,136 @@
           <a:gsLst>
             <a:gs pos="0">
               <a:schemeClr val="phClr">
-                <a:tint val="50000"/>
-                <a:satMod val="300000"/>
+                <a:lumMod val="110000"/>
+                <a:satMod val="105000"/>
+                <a:tint val="67000"/>
               </a:schemeClr>
             </a:gs>
-            <a:gs pos="35000">
+            <a:gs pos="50000">
               <a:schemeClr val="phClr">
-                <a:tint val="37000"/>
-                <a:satMod val="300000"/>
+                <a:lumMod val="105000"/>
+                <a:satMod val="103000"/>
+                <a:tint val="73000"/>
               </a:schemeClr>
             </a:gs>
             <a:gs pos="100000">
               <a:schemeClr val="phClr">
-                <a:tint val="15000"/>
-                <a:satMod val="350000"/>
+                <a:lumMod val="105000"/>
+                <a:satMod val="109000"/>
+                <a:tint val="81000"/>
               </a:schemeClr>
             </a:gs>
           </a:gsLst>
-          <a:lin ang="16200000" scaled="1"/>
+          <a:lin ang="5400000" scaled="0"/>
         </a:gradFill>
         <a:gradFill rotWithShape="1">
           <a:gsLst>
             <a:gs pos="0">
               <a:schemeClr val="phClr">
-                <a:tint val="100000"/>
+                <a:satMod val="103000"/>
+                <a:lumMod val="102000"/>
+                <a:tint val="94000"/>
+              </a:schemeClr>
+            </a:gs>
+            <a:gs pos="50000">
+              <a:schemeClr val="phClr">
+                <a:satMod val="110000"/>
+                <a:lumMod val="100000"/>
                 <a:shade val="100000"/>
-                <a:satMod val="130000"/>
               </a:schemeClr>
             </a:gs>
             <a:gs pos="100000">
               <a:schemeClr val="phClr">
-                <a:tint val="50000"/>
-                <a:shade val="100000"/>
-                <a:satMod val="350000"/>
+                <a:lumMod val="99000"/>
+                <a:satMod val="120000"/>
+                <a:shade val="78000"/>
               </a:schemeClr>
             </a:gs>
           </a:gsLst>
-          <a:lin ang="16200000" scaled="0"/>
+          <a:lin ang="5400000" scaled="0"/>
         </a:gradFill>
       </a:fillStyleLst>
       <a:lnStyleLst>
-        <a:ln w="9525" cap="flat" cmpd="sng" algn="ctr">
+        <a:ln w="12700" cap="flat" cmpd="sng" algn="ctr">
           <a:solidFill>
-            <a:schemeClr val="phClr">
-              <a:shade val="95000"/>
-              <a:satMod val="105000"/>
-            </a:schemeClr>
+            <a:schemeClr val="phClr"/>
           </a:solidFill>
           <a:prstDash val="solid"/>
+          <a:miter lim="800000"/>
+        </a:ln>
+        <a:ln w="19050" cap="flat" cmpd="sng" algn="ctr">
+          <a:solidFill>
+            <a:schemeClr val="phClr"/>
+          </a:solidFill>
+          <a:prstDash val="solid"/>
+          <a:miter lim="800000"/>
         </a:ln>
         <a:ln w="25400" cap="flat" cmpd="sng" algn="ctr">
           <a:solidFill>
             <a:schemeClr val="phClr"/>
           </a:solidFill>
           <a:prstDash val="solid"/>
-        </a:ln>
-        <a:ln w="38100" cap="flat" cmpd="sng" algn="ctr">
-          <a:solidFill>
-            <a:schemeClr val="phClr"/>
-          </a:solidFill>
-          <a:prstDash val="solid"/>
+          <a:miter lim="800000"/>
         </a:ln>
       </a:lnStyleLst>
       <a:effectStyleLst>
         <a:effectStyle>
+          <a:effectLst/>
+        </a:effectStyle>
+        <a:effectStyle>
+          <a:effectLst/>
+        </a:effectStyle>
+        <a:effectStyle>
           <a:effectLst>
-            <a:outerShdw blurRad="40000" dist="20000" dir="5400000" rotWithShape="0">
+            <a:outerShdw blurRad="57150" dist="19050" dir="5400000" algn="ctr" rotWithShape="0">
               <a:srgbClr val="000000">
-                <a:alpha val="38000"/>
+                <a:alpha val="63000"/>
               </a:srgbClr>
             </a:outerShdw>
           </a:effectLst>
-        </a:effectStyle>
-        <a:effectStyle>
-          <a:effectLst>
-            <a:outerShdw blurRad="40000" dist="23000" dir="5400000" rotWithShape="0">
-              <a:srgbClr val="000000">
-                <a:alpha val="35000"/>
-              </a:srgbClr>
-            </a:outerShdw>
-          </a:effectLst>
-        </a:effectStyle>
-        <a:effectStyle>
-          <a:effectLst>
-            <a:outerShdw blurRad="40000" dist="23000" dir="5400000" rotWithShape="0">
-              <a:srgbClr val="000000">
-                <a:alpha val="35000"/>
-              </a:srgbClr>
-            </a:outerShdw>
-          </a:effectLst>
-          <a:scene3d>
-            <a:camera prst="orthographicFront">
-              <a:rot lat="0" lon="0" rev="0"/>
-            </a:camera>
-            <a:lightRig rig="threePt" dir="t">
-              <a:rot lat="0" lon="0" rev="1200000"/>
-            </a:lightRig>
-          </a:scene3d>
-          <a:sp3d>
-            <a:bevelT w="63500" h="25400"/>
-          </a:sp3d>
         </a:effectStyle>
       </a:effectStyleLst>
       <a:bgFillStyleLst>
         <a:solidFill>
           <a:schemeClr val="phClr"/>
         </a:solidFill>
+        <a:solidFill>
+          <a:schemeClr val="phClr">
+            <a:tint val="95000"/>
+            <a:satMod val="170000"/>
+          </a:schemeClr>
+        </a:solidFill>
         <a:gradFill rotWithShape="1">
           <a:gsLst>
             <a:gs pos="0">
               <a:schemeClr val="phClr">
-                <a:tint val="40000"/>
-                <a:satMod val="350000"/>
+                <a:tint val="93000"/>
+                <a:satMod val="150000"/>
+                <a:shade val="98000"/>
+                <a:lumMod val="102000"/>
               </a:schemeClr>
             </a:gs>
-            <a:gs pos="40000">
+            <a:gs pos="50000">
               <a:schemeClr val="phClr">
-                <a:tint val="45000"/>
-                <a:shade val="99000"/>
-                <a:satMod val="350000"/>
+                <a:tint val="98000"/>
+                <a:satMod val="130000"/>
+                <a:shade val="90000"/>
+                <a:lumMod val="103000"/>
               </a:schemeClr>
             </a:gs>
             <a:gs pos="100000">
               <a:schemeClr val="phClr">
-                <a:shade val="20000"/>
-                <a:satMod val="255000"/>
+                <a:shade val="63000"/>
+                <a:satMod val="120000"/>
               </a:schemeClr>
             </a:gs>
           </a:gsLst>
-          <a:path path="circle">
-            <a:fillToRect l="50000" t="-80000" r="50000" b="180000"/>
-          </a:path>
-        </a:gradFill>
-        <a:gradFill rotWithShape="1">
-          <a:gsLst>
-            <a:gs pos="0">
-              <a:schemeClr val="phClr">
-                <a:tint val="80000"/>
-                <a:satMod val="300000"/>
-              </a:schemeClr>
-            </a:gs>
-            <a:gs pos="100000">
-              <a:schemeClr val="phClr">
-                <a:shade val="30000"/>
-                <a:satMod val="200000"/>
-              </a:schemeClr>
-            </a:gs>
-          </a:gsLst>
-          <a:path path="circle">
-            <a:fillToRect l="50000" t="50000" r="50000" b="50000"/>
-          </a:path>
+          <a:lin ang="5400000" scaled="0"/>
         </a:gradFill>
       </a:bgFillStyleLst>
     </a:fmtScheme>
   </a:themeElements>
   <a:objectDefaults>
-    <a:spDef>
-      <a:spPr/>
-      <a:bodyPr/>
-      <a:lstStyle/>
-      <a:style>
-        <a:lnRef idx="1">
-          <a:schemeClr val="accent1"/>
-        </a:lnRef>
-        <a:fillRef idx="3">
-          <a:schemeClr val="accent1"/>
-        </a:fillRef>
-        <a:effectRef idx="2">
-          <a:schemeClr val="accent1"/>
-        </a:effectRef>
-        <a:fontRef idx="minor">
-          <a:schemeClr val="lt1"/>
-        </a:fontRef>
-      </a:style>
-    </a:spDef>
     <a:lnDef>
       <a:spPr/>
       <a:bodyPr/>
@@ -10134,5 +10220,10 @@
     </a:lnDef>
   </a:objectDefaults>
   <a:extraClrSchemeLst/>
+  <a:extLst>
+    <a:ext uri="{05A4C25C-085E-4340-85A3-A5531E510DB2}">
+      <thm15:themeFamily xmlns:thm15="http://schemas.microsoft.com/office/thememl/2012/main" name="Office Theme" id="{2E142A2C-CD16-42D6-873A-C26D2A0506FA}" vid="{1BDDFF52-6CD6-40A5-AB3C-68EB2F1E4D0A}"/>
+    </a:ext>
+  </a:extLst>
 </a:theme>
 </file>
</xml_diff>